<commit_message>
Prezentacija sa obrađenim svojstvima potpunosti i točnosti
</commit_message>
<xml_diff>
--- a/Distribuirani procesi(1).pptx
+++ b/Distribuirani procesi(1).pptx
@@ -11,6 +11,12 @@
     <p:sldId id="260" r:id="rId5"/>
     <p:sldId id="263" r:id="rId6"/>
     <p:sldId id="264" r:id="rId7"/>
+    <p:sldId id="265" r:id="rId8"/>
+    <p:sldId id="266" r:id="rId9"/>
+    <p:sldId id="267" r:id="rId10"/>
+    <p:sldId id="268" r:id="rId11"/>
+    <p:sldId id="269" r:id="rId12"/>
+    <p:sldId id="270" r:id="rId13"/>
   </p:sldIdLst>
   <p:sldSz cx="12192000" cy="6858000"/>
   <p:notesSz cx="6858000" cy="9144000"/>
@@ -120,7 +126,7 @@
 <file path=ppt/revisionInfo.xml><?xml version="1.0" encoding="utf-8"?>
 <p1510:revInfo xmlns:a="http://schemas.openxmlformats.org/drawingml/2006/main" xmlns:r="http://schemas.openxmlformats.org/officeDocument/2006/relationships" xmlns:p1510="http://schemas.microsoft.com/office/powerpoint/2015/10/main">
   <p1510:revLst>
-    <p1510:client id="{B5FEA125-9679-F339-C298-91F1D2692C9D}" v="511" dt="2026-05-31T17:38:57.174"/>
+    <p1510:client id="{F15753D1-93F3-2B3D-E99A-E7E31308B6C8}" v="664" dt="2026-06-25T21:06:35.496"/>
   </p1510:revLst>
 </p1510:revInfo>
 </file>
@@ -626,7 +632,7 @@
             <a:fld id="{B61BEF0D-F0BB-DE4B-95CE-6DB70DBA9567}" type="datetimeFigureOut">
               <a:rPr lang="en-US" dirty="0"/>
               <a:pPr/>
-              <a:t>6/24/2026</a:t>
+              <a:t>6/25/2026</a:t>
             </a:fld>
             <a:endParaRPr lang="en-US" dirty="0"/>
           </a:p>
@@ -919,7 +925,7 @@
             <a:fld id="{B61BEF0D-F0BB-DE4B-95CE-6DB70DBA9567}" type="datetimeFigureOut">
               <a:rPr lang="en-US" dirty="0"/>
               <a:pPr/>
-              <a:t>6/24/2026</a:t>
+              <a:t>6/25/2026</a:t>
             </a:fld>
             <a:endParaRPr lang="en-US" dirty="0"/>
           </a:p>
@@ -1168,7 +1174,7 @@
             <a:fld id="{B61BEF0D-F0BB-DE4B-95CE-6DB70DBA9567}" type="datetimeFigureOut">
               <a:rPr lang="en-US" dirty="0"/>
               <a:pPr/>
-              <a:t>6/24/2026</a:t>
+              <a:t>6/25/2026</a:t>
             </a:fld>
             <a:endParaRPr lang="en-US" dirty="0"/>
           </a:p>
@@ -1709,7 +1715,7 @@
             <a:fld id="{B61BEF0D-F0BB-DE4B-95CE-6DB70DBA9567}" type="datetimeFigureOut">
               <a:rPr lang="en-US" dirty="0"/>
               <a:pPr/>
-              <a:t>6/24/2026</a:t>
+              <a:t>6/25/2026</a:t>
             </a:fld>
             <a:endParaRPr lang="en-US" dirty="0"/>
           </a:p>
@@ -1958,7 +1964,7 @@
             <a:fld id="{B61BEF0D-F0BB-DE4B-95CE-6DB70DBA9567}" type="datetimeFigureOut">
               <a:rPr lang="en-US" dirty="0"/>
               <a:pPr/>
-              <a:t>6/24/2026</a:t>
+              <a:t>6/25/2026</a:t>
             </a:fld>
             <a:endParaRPr lang="en-US" dirty="0"/>
           </a:p>
@@ -2491,7 +2497,7 @@
             <a:fld id="{B61BEF0D-F0BB-DE4B-95CE-6DB70DBA9567}" type="datetimeFigureOut">
               <a:rPr lang="en-US" dirty="0"/>
               <a:pPr/>
-              <a:t>6/24/2026</a:t>
+              <a:t>6/25/2026</a:t>
             </a:fld>
             <a:endParaRPr lang="en-US" dirty="0"/>
           </a:p>
@@ -2789,7 +2795,7 @@
             <a:fld id="{B61BEF0D-F0BB-DE4B-95CE-6DB70DBA9567}" type="datetimeFigureOut">
               <a:rPr lang="en-US" dirty="0"/>
               <a:pPr/>
-              <a:t>6/24/2026</a:t>
+              <a:t>6/25/2026</a:t>
             </a:fld>
             <a:endParaRPr lang="en-US" dirty="0"/>
           </a:p>
@@ -2963,7 +2969,7 @@
             <a:fld id="{B61BEF0D-F0BB-DE4B-95CE-6DB70DBA9567}" type="datetimeFigureOut">
               <a:rPr lang="en-US" dirty="0"/>
               <a:pPr/>
-              <a:t>6/24/2026</a:t>
+              <a:t>6/25/2026</a:t>
             </a:fld>
             <a:endParaRPr lang="en-US" dirty="0"/>
           </a:p>
@@ -3143,7 +3149,7 @@
             <a:fld id="{B61BEF0D-F0BB-DE4B-95CE-6DB70DBA9567}" type="datetimeFigureOut">
               <a:rPr lang="en-US" dirty="0"/>
               <a:pPr/>
-              <a:t>6/24/2026</a:t>
+              <a:t>6/25/2026</a:t>
             </a:fld>
             <a:endParaRPr lang="en-US" dirty="0"/>
           </a:p>
@@ -3313,7 +3319,7 @@
             <a:fld id="{B61BEF0D-F0BB-DE4B-95CE-6DB70DBA9567}" type="datetimeFigureOut">
               <a:rPr lang="en-US" dirty="0"/>
               <a:pPr/>
-              <a:t>6/24/2026</a:t>
+              <a:t>6/25/2026</a:t>
             </a:fld>
             <a:endParaRPr lang="en-US" dirty="0"/>
           </a:p>
@@ -3565,7 +3571,7 @@
             <a:fld id="{B61BEF0D-F0BB-DE4B-95CE-6DB70DBA9567}" type="datetimeFigureOut">
               <a:rPr lang="en-US" dirty="0"/>
               <a:pPr/>
-              <a:t>6/24/2026</a:t>
+              <a:t>6/25/2026</a:t>
             </a:fld>
             <a:endParaRPr lang="en-US" dirty="0"/>
           </a:p>
@@ -3861,7 +3867,7 @@
             <a:fld id="{B61BEF0D-F0BB-DE4B-95CE-6DB70DBA9567}" type="datetimeFigureOut">
               <a:rPr lang="en-US" dirty="0"/>
               <a:pPr/>
-              <a:t>6/24/2026</a:t>
+              <a:t>6/25/2026</a:t>
             </a:fld>
             <a:endParaRPr lang="en-US" dirty="0"/>
           </a:p>
@@ -4302,7 +4308,7 @@
             <a:fld id="{B61BEF0D-F0BB-DE4B-95CE-6DB70DBA9567}" type="datetimeFigureOut">
               <a:rPr lang="en-US" dirty="0"/>
               <a:pPr/>
-              <a:t>6/24/2026</a:t>
+              <a:t>6/25/2026</a:t>
             </a:fld>
             <a:endParaRPr lang="en-US" dirty="0"/>
           </a:p>
@@ -4421,7 +4427,7 @@
             <a:fld id="{B61BEF0D-F0BB-DE4B-95CE-6DB70DBA9567}" type="datetimeFigureOut">
               <a:rPr lang="en-US" dirty="0"/>
               <a:pPr/>
-              <a:t>6/24/2026</a:t>
+              <a:t>6/25/2026</a:t>
             </a:fld>
             <a:endParaRPr lang="en-US" dirty="0"/>
           </a:p>
@@ -4518,7 +4524,7 @@
             <a:fld id="{B61BEF0D-F0BB-DE4B-95CE-6DB70DBA9567}" type="datetimeFigureOut">
               <a:rPr lang="en-US" dirty="0"/>
               <a:pPr/>
-              <a:t>6/24/2026</a:t>
+              <a:t>6/25/2026</a:t>
             </a:fld>
             <a:endParaRPr lang="en-US" dirty="0"/>
           </a:p>
@@ -4801,7 +4807,7 @@
             <a:fld id="{B61BEF0D-F0BB-DE4B-95CE-6DB70DBA9567}" type="datetimeFigureOut">
               <a:rPr lang="en-US" dirty="0"/>
               <a:pPr/>
-              <a:t>6/24/2026</a:t>
+              <a:t>6/25/2026</a:t>
             </a:fld>
             <a:endParaRPr lang="en-US" dirty="0"/>
           </a:p>
@@ -5089,7 +5095,7 @@
             <a:fld id="{B61BEF0D-F0BB-DE4B-95CE-6DB70DBA9567}" type="datetimeFigureOut">
               <a:rPr lang="en-US" dirty="0"/>
               <a:pPr/>
-              <a:t>6/24/2026</a:t>
+              <a:t>6/25/2026</a:t>
             </a:fld>
             <a:endParaRPr lang="en-US" dirty="0"/>
           </a:p>
@@ -5619,7 +5625,7 @@
             <a:fld id="{B61BEF0D-F0BB-DE4B-95CE-6DB70DBA9567}" type="datetimeFigureOut">
               <a:rPr lang="en-US" dirty="0"/>
               <a:pPr/>
-              <a:t>6/24/2026</a:t>
+              <a:t>6/25/2026</a:t>
             </a:fld>
             <a:endParaRPr lang="en-US" dirty="0"/>
           </a:p>
@@ -6218,6 +6224,712 @@
 </p:sld>
 </file>
 
+<file path=ppt/slides/slide10.xml><?xml version="1.0" encoding="utf-8"?>
+<p:sld xmlns:a="http://schemas.openxmlformats.org/drawingml/2006/main" xmlns:r="http://schemas.openxmlformats.org/officeDocument/2006/relationships" xmlns:p="http://schemas.openxmlformats.org/presentationml/2006/main">
+  <p:cSld>
+    <p:spTree>
+      <p:nvGrpSpPr>
+        <p:cNvPr id="1" name=""/>
+        <p:cNvGrpSpPr/>
+        <p:nvPr/>
+      </p:nvGrpSpPr>
+      <p:grpSpPr>
+        <a:xfrm>
+          <a:off x="0" y="0"/>
+          <a:ext cx="0" cy="0"/>
+          <a:chOff x="0" y="0"/>
+          <a:chExt cx="0" cy="0"/>
+        </a:xfrm>
+      </p:grpSpPr>
+      <p:sp>
+        <p:nvSpPr>
+          <p:cNvPr id="2" name="Naslov 1">
+            <a:extLst>
+              <a:ext uri="{FF2B5EF4-FFF2-40B4-BE49-F238E27FC236}">
+                <a16:creationId xmlns:a16="http://schemas.microsoft.com/office/drawing/2014/main" id="{8F718D80-197E-B7ED-58B1-6D00B28B1A9A}"/>
+              </a:ext>
+            </a:extLst>
+          </p:cNvPr>
+          <p:cNvSpPr>
+            <a:spLocks noGrp="1"/>
+          </p:cNvSpPr>
+          <p:nvPr>
+            <p:ph type="title"/>
+          </p:nvPr>
+        </p:nvSpPr>
+        <p:spPr/>
+        <p:txBody>
+          <a:bodyPr/>
+          <a:lstStyle/>
+          <a:p>
+            <a:r>
+              <a:rPr lang="hr-HR"/>
+              <a:t>Potpunost </a:t>
+            </a:r>
+          </a:p>
+        </p:txBody>
+      </p:sp>
+      <p:sp>
+        <p:nvSpPr>
+          <p:cNvPr id="3" name="Rezervirano mjesto sadržaja 2">
+            <a:extLst>
+              <a:ext uri="{FF2B5EF4-FFF2-40B4-BE49-F238E27FC236}">
+                <a16:creationId xmlns:a16="http://schemas.microsoft.com/office/drawing/2014/main" id="{71B4E35C-5EDA-625D-9829-17706258C8DD}"/>
+              </a:ext>
+            </a:extLst>
+          </p:cNvPr>
+          <p:cNvSpPr>
+            <a:spLocks noGrp="1"/>
+          </p:cNvSpPr>
+          <p:nvPr>
+            <p:ph idx="1"/>
+          </p:nvPr>
+        </p:nvSpPr>
+        <p:spPr/>
+        <p:txBody>
+          <a:bodyPr/>
+          <a:lstStyle/>
+          <a:p>
+            <a:r>
+              <a:rPr lang="hr-HR"/>
+              <a:t>Jaka potpunost: </a:t>
+            </a:r>
+            <a:r>
+              <a:rPr lang="hr-HR">
+                <a:latin typeface="Corbel"/>
+              </a:rPr>
+              <a:t>Naposljetku, svaki proces koji se srušio postaje trajno sumnjiv </a:t>
+            </a:r>
+            <a:r>
+              <a:rPr lang="hr-HR" u="sng">
+                <a:latin typeface="Corbel"/>
+              </a:rPr>
+              <a:t>svakom</a:t>
+            </a:r>
+            <a:r>
+              <a:rPr lang="hr-HR">
+                <a:latin typeface="Corbel"/>
+              </a:rPr>
+              <a:t> ispravnom procesu</a:t>
+            </a:r>
+          </a:p>
+          <a:p>
+            <a:pPr>
+              <a:buClr>
+                <a:srgbClr val="1287C3"/>
+              </a:buClr>
+            </a:pPr>
+            <a:endParaRPr lang="hr-HR" dirty="0">
+              <a:latin typeface="Corbel"/>
+              <a:ea typeface="+mn-lt"/>
+              <a:cs typeface="+mn-lt"/>
+            </a:endParaRPr>
+          </a:p>
+          <a:p>
+            <a:pPr marL="0" indent="0">
+              <a:buClr>
+                <a:srgbClr val="1287C3"/>
+              </a:buClr>
+              <a:buNone/>
+            </a:pPr>
+            <a:endParaRPr lang="hr-HR" dirty="0">
+              <a:latin typeface="Corbel"/>
+              <a:ea typeface="+mn-lt"/>
+              <a:cs typeface="+mn-lt"/>
+            </a:endParaRPr>
+          </a:p>
+          <a:p>
+            <a:pPr>
+              <a:buClr>
+                <a:srgbClr val="1287C3"/>
+              </a:buClr>
+            </a:pPr>
+            <a:r>
+              <a:rPr lang="hr-HR">
+                <a:latin typeface="Corbel"/>
+                <a:ea typeface="+mn-lt"/>
+                <a:cs typeface="+mn-lt"/>
+              </a:rPr>
+              <a:t>Slaba potpunost: Naposljetku, svaki proces koji se srušio postaje trajno sumnjiv </a:t>
+            </a:r>
+            <a:r>
+              <a:rPr lang="hr-HR" u="sng">
+                <a:latin typeface="Corbel"/>
+                <a:ea typeface="+mn-lt"/>
+                <a:cs typeface="+mn-lt"/>
+              </a:rPr>
+              <a:t>nekom</a:t>
+            </a:r>
+            <a:r>
+              <a:rPr lang="hr-HR">
+                <a:latin typeface="Corbel"/>
+                <a:ea typeface="+mn-lt"/>
+                <a:cs typeface="+mn-lt"/>
+              </a:rPr>
+              <a:t> ispravnom procesu</a:t>
+            </a:r>
+          </a:p>
+        </p:txBody>
+      </p:sp>
+      <p:pic>
+        <p:nvPicPr>
+          <p:cNvPr id="4" name="Slika 3" descr="Slika na kojoj se prikazuje tekst, snimka zaslona, softver, Multimedijski softver&#10;&#10;Sadržaj generiran uz AI možda nije točan.">
+            <a:extLst>
+              <a:ext uri="{FF2B5EF4-FFF2-40B4-BE49-F238E27FC236}">
+                <a16:creationId xmlns:a16="http://schemas.microsoft.com/office/drawing/2014/main" id="{D1BE1460-8CC7-F84C-EFE1-09384EF53FF8}"/>
+              </a:ext>
+            </a:extLst>
+          </p:cNvPr>
+          <p:cNvPicPr>
+            <a:picLocks noChangeAspect="1"/>
+          </p:cNvPicPr>
+          <p:nvPr/>
+        </p:nvPicPr>
+        <p:blipFill>
+          <a:blip r:embed="rId2"/>
+          <a:srcRect l="45714" t="67802" r="18452" b="27912"/>
+          <a:stretch>
+            <a:fillRect/>
+          </a:stretch>
+        </p:blipFill>
+        <p:spPr>
+          <a:xfrm>
+            <a:off x="1821543" y="3806372"/>
+            <a:ext cx="6451621" cy="420927"/>
+          </a:xfrm>
+          <a:prstGeom prst="rect">
+            <a:avLst/>
+          </a:prstGeom>
+        </p:spPr>
+      </p:pic>
+      <p:pic>
+        <p:nvPicPr>
+          <p:cNvPr id="5" name="Slika 4" descr="Slika na kojoj se prikazuje tekst, snimka zaslona, softver, Multimedijski softver&#10;&#10;Sadržaj generiran uz AI možda nije točan.">
+            <a:extLst>
+              <a:ext uri="{FF2B5EF4-FFF2-40B4-BE49-F238E27FC236}">
+                <a16:creationId xmlns:a16="http://schemas.microsoft.com/office/drawing/2014/main" id="{BE50AFBC-C907-98C5-82CA-D23B343D97D5}"/>
+              </a:ext>
+            </a:extLst>
+          </p:cNvPr>
+          <p:cNvPicPr>
+            <a:picLocks noChangeAspect="1"/>
+          </p:cNvPicPr>
+          <p:nvPr/>
+        </p:nvPicPr>
+        <p:blipFill>
+          <a:blip r:embed="rId2"/>
+          <a:srcRect l="45536" t="80989" r="18333" b="14020"/>
+          <a:stretch>
+            <a:fillRect/>
+          </a:stretch>
+        </p:blipFill>
+        <p:spPr>
+          <a:xfrm>
+            <a:off x="1821543" y="5656943"/>
+            <a:ext cx="6451607" cy="474776"/>
+          </a:xfrm>
+          <a:prstGeom prst="rect">
+            <a:avLst/>
+          </a:prstGeom>
+        </p:spPr>
+      </p:pic>
+    </p:spTree>
+    <p:extLst>
+      <p:ext uri="{BB962C8B-B14F-4D97-AF65-F5344CB8AC3E}">
+        <p14:creationId xmlns:p14="http://schemas.microsoft.com/office/powerpoint/2010/main" val="2106637356"/>
+      </p:ext>
+    </p:extLst>
+  </p:cSld>
+  <p:clrMapOvr>
+    <a:masterClrMapping/>
+  </p:clrMapOvr>
+</p:sld>
+</file>
+
+<file path=ppt/slides/slide11.xml><?xml version="1.0" encoding="utf-8"?>
+<p:sld xmlns:a="http://schemas.openxmlformats.org/drawingml/2006/main" xmlns:r="http://schemas.openxmlformats.org/officeDocument/2006/relationships" xmlns:p="http://schemas.openxmlformats.org/presentationml/2006/main">
+  <p:cSld>
+    <p:spTree>
+      <p:nvGrpSpPr>
+        <p:cNvPr id="1" name=""/>
+        <p:cNvGrpSpPr/>
+        <p:nvPr/>
+      </p:nvGrpSpPr>
+      <p:grpSpPr>
+        <a:xfrm>
+          <a:off x="0" y="0"/>
+          <a:ext cx="0" cy="0"/>
+          <a:chOff x="0" y="0"/>
+          <a:chExt cx="0" cy="0"/>
+        </a:xfrm>
+      </p:grpSpPr>
+      <p:sp>
+        <p:nvSpPr>
+          <p:cNvPr id="2" name="Naslov 1">
+            <a:extLst>
+              <a:ext uri="{FF2B5EF4-FFF2-40B4-BE49-F238E27FC236}">
+                <a16:creationId xmlns:a16="http://schemas.microsoft.com/office/drawing/2014/main" id="{9ABF94AD-7929-55B7-CF45-F955007B1290}"/>
+              </a:ext>
+            </a:extLst>
+          </p:cNvPr>
+          <p:cNvSpPr>
+            <a:spLocks noGrp="1"/>
+          </p:cNvSpPr>
+          <p:nvPr>
+            <p:ph type="title"/>
+          </p:nvPr>
+        </p:nvSpPr>
+        <p:spPr/>
+        <p:txBody>
+          <a:bodyPr/>
+          <a:lstStyle/>
+          <a:p>
+            <a:r>
+              <a:rPr lang="hr-HR"/>
+              <a:t>Točnost</a:t>
+            </a:r>
+          </a:p>
+        </p:txBody>
+      </p:sp>
+      <p:sp>
+        <p:nvSpPr>
+          <p:cNvPr id="3" name="Rezervirano mjesto sadržaja 2">
+            <a:extLst>
+              <a:ext uri="{FF2B5EF4-FFF2-40B4-BE49-F238E27FC236}">
+                <a16:creationId xmlns:a16="http://schemas.microsoft.com/office/drawing/2014/main" id="{1ED751E5-909B-6AA9-9B9C-58AE11DD71DD}"/>
+              </a:ext>
+            </a:extLst>
+          </p:cNvPr>
+          <p:cNvSpPr>
+            <a:spLocks noGrp="1"/>
+          </p:cNvSpPr>
+          <p:nvPr>
+            <p:ph idx="1"/>
+          </p:nvPr>
+        </p:nvSpPr>
+        <p:spPr/>
+        <p:txBody>
+          <a:bodyPr/>
+          <a:lstStyle/>
+          <a:p>
+            <a:r>
+              <a:rPr lang="hr-HR"/>
+              <a:t>Jaka točnost: </a:t>
+            </a:r>
+            <a:r>
+              <a:rPr lang="hr-HR">
+                <a:ea typeface="+mn-lt"/>
+                <a:cs typeface="+mn-lt"/>
+              </a:rPr>
+              <a:t>Ispravni procesi nikada nisu sumnjivi nijednom ispravnom procesu</a:t>
+            </a:r>
+            <a:endParaRPr lang="hr-HR" dirty="0">
+              <a:ea typeface="+mn-lt"/>
+              <a:cs typeface="+mn-lt"/>
+            </a:endParaRPr>
+          </a:p>
+          <a:p>
+            <a:pPr>
+              <a:buClr>
+                <a:srgbClr val="1287C3"/>
+              </a:buClr>
+            </a:pPr>
+            <a:endParaRPr lang="hr-HR" dirty="0">
+              <a:ea typeface="+mn-lt"/>
+              <a:cs typeface="+mn-lt"/>
+            </a:endParaRPr>
+          </a:p>
+          <a:p>
+            <a:pPr>
+              <a:buClr>
+                <a:srgbClr val="1287C3"/>
+              </a:buClr>
+            </a:pPr>
+            <a:r>
+              <a:rPr lang="hr-HR">
+                <a:ea typeface="+mn-lt"/>
+                <a:cs typeface="+mn-lt"/>
+              </a:rPr>
+              <a:t>Slaba točnost: Neki ispravan proces nikad nije sumnjiv nijednom ispravnom procesu</a:t>
+            </a:r>
+          </a:p>
+          <a:p>
+            <a:pPr>
+              <a:buClr>
+                <a:srgbClr val="1287C3"/>
+              </a:buClr>
+            </a:pPr>
+            <a:endParaRPr lang="hr-HR" dirty="0">
+              <a:ea typeface="+mn-lt"/>
+              <a:cs typeface="+mn-lt"/>
+            </a:endParaRPr>
+          </a:p>
+          <a:p>
+            <a:pPr>
+              <a:buClr>
+                <a:srgbClr val="1287C3"/>
+              </a:buClr>
+            </a:pPr>
+            <a:endParaRPr lang="hr-HR" dirty="0">
+              <a:ea typeface="+mn-lt"/>
+              <a:cs typeface="+mn-lt"/>
+            </a:endParaRPr>
+          </a:p>
+        </p:txBody>
+      </p:sp>
+      <p:pic>
+        <p:nvPicPr>
+          <p:cNvPr id="4" name="Slika 3" descr="Slika na kojoj se prikazuje tekst, snimka zaslona, softver, Multimedijski softver&#10;&#10;Sadržaj generiran uz AI možda nije točan.">
+            <a:extLst>
+              <a:ext uri="{FF2B5EF4-FFF2-40B4-BE49-F238E27FC236}">
+                <a16:creationId xmlns:a16="http://schemas.microsoft.com/office/drawing/2014/main" id="{F982BF18-BC41-30B5-1412-C56989043F4D}"/>
+              </a:ext>
+            </a:extLst>
+          </p:cNvPr>
+          <p:cNvPicPr>
+            <a:picLocks noChangeAspect="1"/>
+          </p:cNvPicPr>
+          <p:nvPr/>
+        </p:nvPicPr>
+        <p:blipFill>
+          <a:blip r:embed="rId2"/>
+          <a:srcRect l="53690" t="59011" r="24702" b="37143"/>
+          <a:stretch>
+            <a:fillRect/>
+          </a:stretch>
+        </p:blipFill>
+        <p:spPr>
+          <a:xfrm>
+            <a:off x="1814286" y="3408992"/>
+            <a:ext cx="4949389" cy="442752"/>
+          </a:xfrm>
+          <a:prstGeom prst="rect">
+            <a:avLst/>
+          </a:prstGeom>
+        </p:spPr>
+      </p:pic>
+      <p:pic>
+        <p:nvPicPr>
+          <p:cNvPr id="5" name="Slika 4" descr="Slika na kojoj se prikazuje tekst, snimka zaslona, softver, Multimedijski softver&#10;&#10;Sadržaj generiran uz AI možda nije točan.">
+            <a:extLst>
+              <a:ext uri="{FF2B5EF4-FFF2-40B4-BE49-F238E27FC236}">
+                <a16:creationId xmlns:a16="http://schemas.microsoft.com/office/drawing/2014/main" id="{9A7805E1-1CE3-A7AB-E6E9-741C7BE4CE11}"/>
+              </a:ext>
+            </a:extLst>
+          </p:cNvPr>
+          <p:cNvPicPr>
+            <a:picLocks noChangeAspect="1"/>
+          </p:cNvPicPr>
+          <p:nvPr/>
+        </p:nvPicPr>
+        <p:blipFill>
+          <a:blip r:embed="rId2"/>
+          <a:srcRect l="51071" t="80000" r="23274" b="15494"/>
+          <a:stretch>
+            <a:fillRect/>
+          </a:stretch>
+        </p:blipFill>
+        <p:spPr>
+          <a:xfrm>
+            <a:off x="1814286" y="4967514"/>
+            <a:ext cx="4949385" cy="471711"/>
+          </a:xfrm>
+          <a:prstGeom prst="rect">
+            <a:avLst/>
+          </a:prstGeom>
+        </p:spPr>
+      </p:pic>
+    </p:spTree>
+    <p:extLst>
+      <p:ext uri="{BB962C8B-B14F-4D97-AF65-F5344CB8AC3E}">
+        <p14:creationId xmlns:p14="http://schemas.microsoft.com/office/powerpoint/2010/main" val="641086459"/>
+      </p:ext>
+    </p:extLst>
+  </p:cSld>
+  <p:clrMapOvr>
+    <a:masterClrMapping/>
+  </p:clrMapOvr>
+</p:sld>
+</file>
+
+<file path=ppt/slides/slide12.xml><?xml version="1.0" encoding="utf-8"?>
+<p:sld xmlns:a="http://schemas.openxmlformats.org/drawingml/2006/main" xmlns:r="http://schemas.openxmlformats.org/officeDocument/2006/relationships" xmlns:p="http://schemas.openxmlformats.org/presentationml/2006/main">
+  <p:cSld>
+    <p:spTree>
+      <p:nvGrpSpPr>
+        <p:cNvPr id="1" name=""/>
+        <p:cNvGrpSpPr/>
+        <p:nvPr/>
+      </p:nvGrpSpPr>
+      <p:grpSpPr>
+        <a:xfrm>
+          <a:off x="0" y="0"/>
+          <a:ext cx="0" cy="0"/>
+          <a:chOff x="0" y="0"/>
+          <a:chExt cx="0" cy="0"/>
+        </a:xfrm>
+      </p:grpSpPr>
+      <p:sp>
+        <p:nvSpPr>
+          <p:cNvPr id="2" name="Naslov 1">
+            <a:extLst>
+              <a:ext uri="{FF2B5EF4-FFF2-40B4-BE49-F238E27FC236}">
+                <a16:creationId xmlns:a16="http://schemas.microsoft.com/office/drawing/2014/main" id="{0A499B02-0A68-A005-EA7F-6CEF49519985}"/>
+              </a:ext>
+            </a:extLst>
+          </p:cNvPr>
+          <p:cNvSpPr>
+            <a:spLocks noGrp="1"/>
+          </p:cNvSpPr>
+          <p:nvPr>
+            <p:ph type="title"/>
+          </p:nvPr>
+        </p:nvSpPr>
+        <p:spPr>
+          <a:xfrm>
+            <a:off x="1484311" y="257629"/>
+            <a:ext cx="10018713" cy="1752599"/>
+          </a:xfrm>
+        </p:spPr>
+        <p:txBody>
+          <a:bodyPr/>
+          <a:lstStyle/>
+          <a:p>
+            <a:r>
+              <a:rPr lang="hr-HR"/>
+              <a:t>Konačna točnost</a:t>
+            </a:r>
+            <a:endParaRPr lang="hr-HR" dirty="0"/>
+          </a:p>
+        </p:txBody>
+      </p:sp>
+      <p:sp>
+        <p:nvSpPr>
+          <p:cNvPr id="3" name="Rezervirano mjesto sadržaja 2">
+            <a:extLst>
+              <a:ext uri="{FF2B5EF4-FFF2-40B4-BE49-F238E27FC236}">
+                <a16:creationId xmlns:a16="http://schemas.microsoft.com/office/drawing/2014/main" id="{22D95497-7763-0263-435D-CA9B5C00AB63}"/>
+              </a:ext>
+            </a:extLst>
+          </p:cNvPr>
+          <p:cNvSpPr>
+            <a:spLocks noGrp="1"/>
+          </p:cNvSpPr>
+          <p:nvPr>
+            <p:ph idx="1"/>
+          </p:nvPr>
+        </p:nvSpPr>
+        <p:spPr>
+          <a:xfrm>
+            <a:off x="1484310" y="1716313"/>
+            <a:ext cx="10018713" cy="5040086"/>
+          </a:xfrm>
+        </p:spPr>
+        <p:txBody>
+          <a:bodyPr>
+            <a:normAutofit/>
+          </a:bodyPr>
+          <a:lstStyle/>
+          <a:p>
+            <a:pPr>
+              <a:lnSpc>
+                <a:spcPct val="80000"/>
+              </a:lnSpc>
+              <a:spcBef>
+                <a:spcPts val="20"/>
+              </a:spcBef>
+            </a:pPr>
+            <a:r>
+              <a:rPr lang="hr-HR"/>
+              <a:t>Čak je i slabu točnost teško postići, jer detektor (čak i pri ispravnom procesu) može posumnjati na ispravan proces, a zatim kasnije ispraviti svoju pogrešku</a:t>
+            </a:r>
+            <a:endParaRPr lang="sr-Latn-RS"/>
+          </a:p>
+          <a:p>
+            <a:pPr>
+              <a:lnSpc>
+                <a:spcPct val="80000"/>
+              </a:lnSpc>
+              <a:spcBef>
+                <a:spcPts val="20"/>
+              </a:spcBef>
+              <a:buClr>
+                <a:srgbClr val="1287C3"/>
+              </a:buClr>
+            </a:pPr>
+            <a:r>
+              <a:rPr lang="hr-HR"/>
+              <a:t>Svojstvo slabe točnosti to ne dopušta, stoga dodatno oslabljujemo zahtjev točnosti i dopuštamo detektore kvarova koji mogu posumnjati na ispravan proces u nekim točkama tijekom izvođenja, ali na kraju zadovoljavaju svojstva jake i slabe točnosti</a:t>
+            </a:r>
+          </a:p>
+          <a:p>
+            <a:pPr>
+              <a:lnSpc>
+                <a:spcPct val="80000"/>
+              </a:lnSpc>
+              <a:spcBef>
+                <a:spcPts val="20"/>
+              </a:spcBef>
+              <a:buClr>
+                <a:srgbClr val="1287C3"/>
+              </a:buClr>
+            </a:pPr>
+            <a:endParaRPr lang="hr-HR" dirty="0"/>
+          </a:p>
+          <a:p>
+            <a:pPr>
+              <a:lnSpc>
+                <a:spcPct val="80000"/>
+              </a:lnSpc>
+              <a:spcBef>
+                <a:spcPts val="20"/>
+              </a:spcBef>
+              <a:buClr>
+                <a:srgbClr val="1287C3"/>
+              </a:buClr>
+            </a:pPr>
+            <a:r>
+              <a:rPr lang="hr-HR">
+                <a:ea typeface="+mn-lt"/>
+                <a:cs typeface="+mn-lt"/>
+              </a:rPr>
+              <a:t>Konačna jaka točnost: Postoji vrijeme nakon kojeg ispravni procesi više nisu sumnjivi nijedanom ispravanom procesu</a:t>
+            </a:r>
+            <a:endParaRPr lang="hr-HR" dirty="0">
+              <a:ea typeface="+mn-lt"/>
+              <a:cs typeface="+mn-lt"/>
+            </a:endParaRPr>
+          </a:p>
+          <a:p>
+            <a:pPr>
+              <a:lnSpc>
+                <a:spcPct val="80000"/>
+              </a:lnSpc>
+              <a:spcBef>
+                <a:spcPts val="20"/>
+              </a:spcBef>
+              <a:buClr>
+                <a:srgbClr val="1287C3"/>
+              </a:buClr>
+            </a:pPr>
+            <a:endParaRPr lang="hr-HR" dirty="0"/>
+          </a:p>
+          <a:p>
+            <a:pPr>
+              <a:lnSpc>
+                <a:spcPct val="80000"/>
+              </a:lnSpc>
+              <a:spcBef>
+                <a:spcPts val="20"/>
+              </a:spcBef>
+              <a:buClr>
+                <a:srgbClr val="1287C3"/>
+              </a:buClr>
+            </a:pPr>
+            <a:r>
+              <a:rPr lang="hr-HR"/>
+              <a:t>Konačna slaba točnost: </a:t>
+            </a:r>
+            <a:r>
+              <a:rPr lang="hr-HR">
+                <a:ea typeface="+mn-lt"/>
+                <a:cs typeface="+mn-lt"/>
+              </a:rPr>
+              <a:t>Postoji vrijeme nakon kojeg neki ispravan proces više nije sumnjiv nijednom ispravnom procesu</a:t>
+            </a:r>
+            <a:endParaRPr lang="hr-HR" dirty="0"/>
+          </a:p>
+          <a:p>
+            <a:pPr>
+              <a:lnSpc>
+                <a:spcPct val="80000"/>
+              </a:lnSpc>
+              <a:spcBef>
+                <a:spcPts val="20"/>
+              </a:spcBef>
+              <a:buClr>
+                <a:srgbClr val="1287C3"/>
+              </a:buClr>
+            </a:pPr>
+            <a:endParaRPr lang="hr-HR" dirty="0"/>
+          </a:p>
+        </p:txBody>
+      </p:sp>
+      <p:pic>
+        <p:nvPicPr>
+          <p:cNvPr id="4" name="Slika 3" descr="Slika na kojoj se prikazuje tekst, snimka zaslona, softver, Multimedijski softver&#10;&#10;Sadržaj generiran uz AI možda nije točan.">
+            <a:extLst>
+              <a:ext uri="{FF2B5EF4-FFF2-40B4-BE49-F238E27FC236}">
+                <a16:creationId xmlns:a16="http://schemas.microsoft.com/office/drawing/2014/main" id="{73414793-C0E4-BC54-ECA9-ACFD27E3699A}"/>
+              </a:ext>
+            </a:extLst>
+          </p:cNvPr>
+          <p:cNvPicPr>
+            <a:picLocks noChangeAspect="1"/>
+          </p:cNvPicPr>
+          <p:nvPr/>
+        </p:nvPicPr>
+        <p:blipFill>
+          <a:blip r:embed="rId2"/>
+          <a:srcRect l="51727" t="43959" r="23491" b="51732"/>
+          <a:stretch>
+            <a:fillRect/>
+          </a:stretch>
+        </p:blipFill>
+        <p:spPr>
+          <a:xfrm>
+            <a:off x="2278743" y="5119914"/>
+            <a:ext cx="4132369" cy="401334"/>
+          </a:xfrm>
+          <a:prstGeom prst="rect">
+            <a:avLst/>
+          </a:prstGeom>
+        </p:spPr>
+      </p:pic>
+      <p:pic>
+        <p:nvPicPr>
+          <p:cNvPr id="5" name="Slika 4" descr="Slika na kojoj se prikazuje tekst, snimka zaslona, softver, Multimedijski softver&#10;&#10;Sadržaj generiran uz AI možda nije točan.">
+            <a:extLst>
+              <a:ext uri="{FF2B5EF4-FFF2-40B4-BE49-F238E27FC236}">
+                <a16:creationId xmlns:a16="http://schemas.microsoft.com/office/drawing/2014/main" id="{7C8C0FC2-E8BC-5452-A565-98151F8E79E3}"/>
+              </a:ext>
+            </a:extLst>
+          </p:cNvPr>
+          <p:cNvPicPr>
+            <a:picLocks noChangeAspect="1"/>
+          </p:cNvPicPr>
+          <p:nvPr/>
+        </p:nvPicPr>
+        <p:blipFill>
+          <a:blip r:embed="rId2"/>
+          <a:srcRect l="49845" t="81868" r="22024" b="13130"/>
+          <a:stretch>
+            <a:fillRect/>
+          </a:stretch>
+        </p:blipFill>
+        <p:spPr>
+          <a:xfrm>
+            <a:off x="2281645" y="6252029"/>
+            <a:ext cx="4126418" cy="402877"/>
+          </a:xfrm>
+          <a:prstGeom prst="rect">
+            <a:avLst/>
+          </a:prstGeom>
+        </p:spPr>
+      </p:pic>
+    </p:spTree>
+    <p:extLst>
+      <p:ext uri="{BB962C8B-B14F-4D97-AF65-F5344CB8AC3E}">
+        <p14:creationId xmlns:p14="http://schemas.microsoft.com/office/powerpoint/2010/main" val="3742418586"/>
+      </p:ext>
+    </p:extLst>
+  </p:cSld>
+  <p:clrMapOvr>
+    <a:masterClrMapping/>
+  </p:clrMapOvr>
+</p:sld>
+</file>
+
 <file path=ppt/slides/slide2.xml><?xml version="1.0" encoding="utf-8"?>
 <p:sld xmlns:a="http://schemas.openxmlformats.org/drawingml/2006/main" xmlns:r="http://schemas.openxmlformats.org/officeDocument/2006/relationships" xmlns:p="http://schemas.openxmlformats.org/presentationml/2006/main">
   <p:cSld>
@@ -6932,7 +7644,21 @@
               </a:rPr>
               <a:t>Crashed(t, Ω) je skup svih procesa koji su se srušili do trenutka t u hodu Ω, dok je  Up(t,Ω) skup onih koji se nisu srušili do trenutka t</a:t>
             </a:r>
-            <a:endParaRPr lang="hr-HR"/>
+          </a:p>
+          <a:p>
+            <a:pPr>
+              <a:buClr>
+                <a:srgbClr val="1287C3"/>
+              </a:buClr>
+            </a:pPr>
+            <a:r>
+              <a:rPr lang="hr-HR">
+                <a:ea typeface="+mn-lt"/>
+                <a:cs typeface="+mn-lt"/>
+              </a:rPr>
+              <a:t>Up(t,Ω ) = Q − Crashed(t,Ω )</a:t>
+            </a:r>
+            <a:endParaRPr lang="hr-HR" dirty="0"/>
           </a:p>
         </p:txBody>
       </p:sp>
@@ -6940,6 +7666,440 @@
     <p:extLst>
       <p:ext uri="{BB962C8B-B14F-4D97-AF65-F5344CB8AC3E}">
         <p14:creationId xmlns:p14="http://schemas.microsoft.com/office/powerpoint/2010/main" val="4133646957"/>
+      </p:ext>
+    </p:extLst>
+  </p:cSld>
+  <p:clrMapOvr>
+    <a:masterClrMapping/>
+  </p:clrMapOvr>
+</p:sld>
+</file>
+
+<file path=ppt/slides/slide7.xml><?xml version="1.0" encoding="utf-8"?>
+<p:sld xmlns:a="http://schemas.openxmlformats.org/drawingml/2006/main" xmlns:r="http://schemas.openxmlformats.org/officeDocument/2006/relationships" xmlns:p="http://schemas.openxmlformats.org/presentationml/2006/main">
+  <p:cSld>
+    <p:spTree>
+      <p:nvGrpSpPr>
+        <p:cNvPr id="1" name=""/>
+        <p:cNvGrpSpPr/>
+        <p:nvPr/>
+      </p:nvGrpSpPr>
+      <p:grpSpPr>
+        <a:xfrm>
+          <a:off x="0" y="0"/>
+          <a:ext cx="0" cy="0"/>
+          <a:chOff x="0" y="0"/>
+          <a:chExt cx="0" cy="0"/>
+        </a:xfrm>
+      </p:grpSpPr>
+      <p:sp>
+        <p:nvSpPr>
+          <p:cNvPr id="2" name="Naslov 1">
+            <a:extLst>
+              <a:ext uri="{FF2B5EF4-FFF2-40B4-BE49-F238E27FC236}">
+                <a16:creationId xmlns:a16="http://schemas.microsoft.com/office/drawing/2014/main" id="{72C4427C-ED8B-7BAD-45CE-9BD50DFE112E}"/>
+              </a:ext>
+            </a:extLst>
+          </p:cNvPr>
+          <p:cNvSpPr>
+            <a:spLocks noGrp="1"/>
+          </p:cNvSpPr>
+          <p:nvPr>
+            <p:ph type="title"/>
+          </p:nvPr>
+        </p:nvSpPr>
+        <p:spPr/>
+        <p:txBody>
+          <a:bodyPr/>
+          <a:lstStyle/>
+          <a:p>
+            <a:r>
+              <a:rPr lang="hr-HR"/>
+              <a:t>Detektori kvarova</a:t>
+            </a:r>
+          </a:p>
+        </p:txBody>
+      </p:sp>
+      <p:sp>
+        <p:nvSpPr>
+          <p:cNvPr id="3" name="Rezervirano mjesto sadržaja 2">
+            <a:extLst>
+              <a:ext uri="{FF2B5EF4-FFF2-40B4-BE49-F238E27FC236}">
+                <a16:creationId xmlns:a16="http://schemas.microsoft.com/office/drawing/2014/main" id="{288663DE-13DB-1305-4460-233028807617}"/>
+              </a:ext>
+            </a:extLst>
+          </p:cNvPr>
+          <p:cNvSpPr>
+            <a:spLocks noGrp="1"/>
+          </p:cNvSpPr>
+          <p:nvPr>
+            <p:ph idx="1"/>
+          </p:nvPr>
+        </p:nvSpPr>
+        <p:spPr/>
+        <p:txBody>
+          <a:bodyPr/>
+          <a:lstStyle/>
+          <a:p>
+            <a:r>
+              <a:rPr lang="hr-HR">
+                <a:latin typeface="Corbel"/>
+              </a:rPr>
+              <a:t>Detektor kvarova D je distribuirani orakl koji daje naznake o kvarovima</a:t>
+            </a:r>
+            <a:endParaRPr lang="sr-Latn-RS"/>
+          </a:p>
+          <a:p>
+            <a:pPr>
+              <a:buClr>
+                <a:srgbClr val="1287C3"/>
+              </a:buClr>
+            </a:pPr>
+            <a:r>
+              <a:rPr lang="hr-HR">
+                <a:latin typeface="Corbel"/>
+              </a:rPr>
+              <a:t>Svaki proces pi u distribuiranom okruženju ima svoj lokalni detektor kvarova D</a:t>
+            </a:r>
+            <a:r>
+              <a:rPr lang="hr-HR" baseline="-25000">
+                <a:latin typeface="Corbel"/>
+              </a:rPr>
+              <a:t>i</a:t>
+            </a:r>
+            <a:r>
+              <a:rPr lang="hr-HR">
+                <a:latin typeface="Corbel"/>
+              </a:rPr>
+              <a:t>, koji prati sve ostale procese i održava popis procesa za koje p</a:t>
+            </a:r>
+            <a:r>
+              <a:rPr lang="hr-HR" baseline="-25000">
+                <a:latin typeface="Corbel"/>
+              </a:rPr>
+              <a:t>i</a:t>
+            </a:r>
+            <a:r>
+              <a:rPr lang="hr-HR">
+                <a:latin typeface="Corbel"/>
+              </a:rPr>
+              <a:t> trenutno sumnja da su se srušili</a:t>
+            </a:r>
+          </a:p>
+          <a:p>
+            <a:pPr>
+              <a:buClr>
+                <a:srgbClr val="1287C3"/>
+              </a:buClr>
+            </a:pPr>
+            <a:r>
+              <a:rPr lang="hr-HR">
+                <a:latin typeface="Corbel"/>
+              </a:rPr>
+              <a:t>Sumnja se temelji na duljini vremena za koje pi nije dobio poruku od drugih procesa </a:t>
+            </a:r>
+            <a:endParaRPr lang="hr-HR"/>
+          </a:p>
+        </p:txBody>
+      </p:sp>
+    </p:spTree>
+    <p:extLst>
+      <p:ext uri="{BB962C8B-B14F-4D97-AF65-F5344CB8AC3E}">
+        <p14:creationId xmlns:p14="http://schemas.microsoft.com/office/powerpoint/2010/main" val="2734291026"/>
+      </p:ext>
+    </p:extLst>
+  </p:cSld>
+  <p:clrMapOvr>
+    <a:masterClrMapping/>
+  </p:clrMapOvr>
+</p:sld>
+</file>
+
+<file path=ppt/slides/slide8.xml><?xml version="1.0" encoding="utf-8"?>
+<p:sld xmlns:a="http://schemas.openxmlformats.org/drawingml/2006/main" xmlns:r="http://schemas.openxmlformats.org/officeDocument/2006/relationships" xmlns:p="http://schemas.openxmlformats.org/presentationml/2006/main">
+  <p:cSld>
+    <p:spTree>
+      <p:nvGrpSpPr>
+        <p:cNvPr id="1" name=""/>
+        <p:cNvGrpSpPr/>
+        <p:nvPr/>
+      </p:nvGrpSpPr>
+      <p:grpSpPr>
+        <a:xfrm>
+          <a:off x="0" y="0"/>
+          <a:ext cx="0" cy="0"/>
+          <a:chOff x="0" y="0"/>
+          <a:chExt cx="0" cy="0"/>
+        </a:xfrm>
+      </p:grpSpPr>
+      <p:sp>
+        <p:nvSpPr>
+          <p:cNvPr id="2" name="Naslov 1">
+            <a:extLst>
+              <a:ext uri="{FF2B5EF4-FFF2-40B4-BE49-F238E27FC236}">
+                <a16:creationId xmlns:a16="http://schemas.microsoft.com/office/drawing/2014/main" id="{3B3961BB-703A-BE3A-A277-686CCCFA241A}"/>
+              </a:ext>
+            </a:extLst>
+          </p:cNvPr>
+          <p:cNvSpPr>
+            <a:spLocks noGrp="1"/>
+          </p:cNvSpPr>
+          <p:nvPr>
+            <p:ph type="title"/>
+          </p:nvPr>
+        </p:nvSpPr>
+        <p:spPr/>
+        <p:txBody>
+          <a:bodyPr/>
+          <a:lstStyle/>
+          <a:p>
+            <a:r>
+              <a:rPr lang="hr-HR"/>
+              <a:t>Detektori kvarova</a:t>
+            </a:r>
+          </a:p>
+        </p:txBody>
+      </p:sp>
+      <p:sp>
+        <p:nvSpPr>
+          <p:cNvPr id="3" name="Rezervirano mjesto sadržaja 2">
+            <a:extLst>
+              <a:ext uri="{FF2B5EF4-FFF2-40B4-BE49-F238E27FC236}">
+                <a16:creationId xmlns:a16="http://schemas.microsoft.com/office/drawing/2014/main" id="{2BDCD600-789C-5916-9F59-C9020E845AF6}"/>
+              </a:ext>
+            </a:extLst>
+          </p:cNvPr>
+          <p:cNvSpPr>
+            <a:spLocks noGrp="1"/>
+          </p:cNvSpPr>
+          <p:nvPr>
+            <p:ph idx="1"/>
+          </p:nvPr>
+        </p:nvSpPr>
+        <p:spPr/>
+        <p:txBody>
+          <a:bodyPr/>
+          <a:lstStyle/>
+          <a:p>
+            <a:r>
+              <a:rPr lang="hr-HR">
+                <a:ea typeface="+mn-lt"/>
+                <a:cs typeface="+mn-lt"/>
+              </a:rPr>
+              <a:t>Detektor kvarova D = &lt;D</a:t>
+            </a:r>
+            <a:r>
+              <a:rPr lang="hr-HR" baseline="-25000">
+                <a:ea typeface="+mn-lt"/>
+                <a:cs typeface="+mn-lt"/>
+              </a:rPr>
+              <a:t>p1</a:t>
+            </a:r>
+            <a:r>
+              <a:rPr lang="hr-HR">
+                <a:ea typeface="+mn-lt"/>
+                <a:cs typeface="+mn-lt"/>
+              </a:rPr>
+              <a:t>, D</a:t>
+            </a:r>
+            <a:r>
+              <a:rPr lang="hr-HR" baseline="-25000">
+                <a:ea typeface="+mn-lt"/>
+                <a:cs typeface="+mn-lt"/>
+              </a:rPr>
+              <a:t>p2</a:t>
+            </a:r>
+            <a:r>
+              <a:rPr lang="hr-HR">
+                <a:ea typeface="+mn-lt"/>
+                <a:cs typeface="+mn-lt"/>
+              </a:rPr>
+              <a:t>,…, D</a:t>
+            </a:r>
+            <a:r>
+              <a:rPr lang="hr-HR" baseline="-25000">
+                <a:ea typeface="+mn-lt"/>
+                <a:cs typeface="+mn-lt"/>
+              </a:rPr>
+              <a:t>pn</a:t>
+            </a:r>
+            <a:r>
+              <a:rPr lang="hr-HR">
+                <a:ea typeface="+mn-lt"/>
+                <a:cs typeface="+mn-lt"/>
+              </a:rPr>
+              <a:t>&gt; gdje je D</a:t>
+            </a:r>
+            <a:r>
+              <a:rPr lang="hr-HR" baseline="-25000">
+                <a:ea typeface="+mn-lt"/>
+                <a:cs typeface="+mn-lt"/>
+              </a:rPr>
+              <a:t>i</a:t>
+            </a:r>
+            <a:r>
+              <a:rPr lang="hr-HR">
+                <a:ea typeface="+mn-lt"/>
+                <a:cs typeface="+mn-lt"/>
+              </a:rPr>
+              <a:t> detektor kvarova za proces p</a:t>
+            </a:r>
+            <a:r>
+              <a:rPr lang="hr-HR" baseline="-25000">
+                <a:ea typeface="+mn-lt"/>
+                <a:cs typeface="+mn-lt"/>
+              </a:rPr>
+              <a:t>i</a:t>
+            </a:r>
+          </a:p>
+          <a:p>
+            <a:pPr>
+              <a:buClr>
+                <a:srgbClr val="1287C3"/>
+              </a:buClr>
+            </a:pPr>
+            <a:r>
+              <a:rPr lang="hr-HR"/>
+              <a:t>D</a:t>
+            </a:r>
+            <a:r>
+              <a:rPr lang="hr-HR" baseline="-25000"/>
+              <a:t>p</a:t>
+            </a:r>
+            <a:r>
+              <a:rPr lang="hr-HR"/>
+              <a:t>(t, Ω) je skup svih procesa za koje p sumnja da su se srušili do trenutka t</a:t>
+            </a:r>
+          </a:p>
+        </p:txBody>
+      </p:sp>
+    </p:spTree>
+    <p:extLst>
+      <p:ext uri="{BB962C8B-B14F-4D97-AF65-F5344CB8AC3E}">
+        <p14:creationId xmlns:p14="http://schemas.microsoft.com/office/powerpoint/2010/main" val="3473397533"/>
+      </p:ext>
+    </p:extLst>
+  </p:cSld>
+  <p:clrMapOvr>
+    <a:masterClrMapping/>
+  </p:clrMapOvr>
+</p:sld>
+</file>
+
+<file path=ppt/slides/slide9.xml><?xml version="1.0" encoding="utf-8"?>
+<p:sld xmlns:a="http://schemas.openxmlformats.org/drawingml/2006/main" xmlns:r="http://schemas.openxmlformats.org/officeDocument/2006/relationships" xmlns:p="http://schemas.openxmlformats.org/presentationml/2006/main">
+  <p:cSld>
+    <p:spTree>
+      <p:nvGrpSpPr>
+        <p:cNvPr id="1" name=""/>
+        <p:cNvGrpSpPr/>
+        <p:nvPr/>
+      </p:nvGrpSpPr>
+      <p:grpSpPr>
+        <a:xfrm>
+          <a:off x="0" y="0"/>
+          <a:ext cx="0" cy="0"/>
+          <a:chOff x="0" y="0"/>
+          <a:chExt cx="0" cy="0"/>
+        </a:xfrm>
+      </p:grpSpPr>
+      <p:sp>
+        <p:nvSpPr>
+          <p:cNvPr id="2" name="Naslov 1">
+            <a:extLst>
+              <a:ext uri="{FF2B5EF4-FFF2-40B4-BE49-F238E27FC236}">
+                <a16:creationId xmlns:a16="http://schemas.microsoft.com/office/drawing/2014/main" id="{7FC834BB-49DD-3AE6-954B-AC96C474BDC2}"/>
+              </a:ext>
+            </a:extLst>
+          </p:cNvPr>
+          <p:cNvSpPr>
+            <a:spLocks noGrp="1"/>
+          </p:cNvSpPr>
+          <p:nvPr>
+            <p:ph type="title"/>
+          </p:nvPr>
+        </p:nvSpPr>
+        <p:spPr/>
+        <p:txBody>
+          <a:bodyPr/>
+          <a:lstStyle/>
+          <a:p>
+            <a:r>
+              <a:rPr lang="hr-HR"/>
+              <a:t>Detektori kvarova</a:t>
+            </a:r>
+          </a:p>
+        </p:txBody>
+      </p:sp>
+      <p:sp>
+        <p:nvSpPr>
+          <p:cNvPr id="3" name="Rezervirano mjesto sadržaja 2">
+            <a:extLst>
+              <a:ext uri="{FF2B5EF4-FFF2-40B4-BE49-F238E27FC236}">
+                <a16:creationId xmlns:a16="http://schemas.microsoft.com/office/drawing/2014/main" id="{70E53F3E-027F-0429-F857-35820FA783F1}"/>
+              </a:ext>
+            </a:extLst>
+          </p:cNvPr>
+          <p:cNvSpPr>
+            <a:spLocks noGrp="1"/>
+          </p:cNvSpPr>
+          <p:nvPr>
+            <p:ph idx="1"/>
+          </p:nvPr>
+        </p:nvSpPr>
+        <p:spPr/>
+        <p:txBody>
+          <a:bodyPr/>
+          <a:lstStyle/>
+          <a:p>
+            <a:r>
+              <a:rPr lang="hr-HR">
+                <a:ea typeface="+mn-lt"/>
+                <a:cs typeface="+mn-lt"/>
+              </a:rPr>
+              <a:t>Detektori kvarova mogu pogriješiti, tj. ispravan proces može biti dodan na popis srušenih, a kasnije uklonjen ako detektor kvarova shvati da je došlo do pogreške</a:t>
+            </a:r>
+          </a:p>
+          <a:p>
+            <a:pPr>
+              <a:buClr>
+                <a:srgbClr val="1287C3"/>
+              </a:buClr>
+            </a:pPr>
+            <a:r>
+              <a:rPr lang="hr-HR"/>
+              <a:t>Imamo 2 svojstva, potpunost i točnost</a:t>
+            </a:r>
+          </a:p>
+          <a:p>
+            <a:pPr>
+              <a:buClr>
+                <a:srgbClr val="1287C3"/>
+              </a:buClr>
+            </a:pPr>
+            <a:r>
+              <a:rPr lang="hr-HR"/>
+              <a:t>Potpunost zahtjeva da detektor nakon nekog vremena sumnja na sve procese koji su se srušili</a:t>
+            </a:r>
+          </a:p>
+          <a:p>
+            <a:pPr>
+              <a:buClr>
+                <a:srgbClr val="1287C3"/>
+              </a:buClr>
+            </a:pPr>
+            <a:r>
+              <a:rPr lang="hr-HR"/>
+              <a:t>Točnost ograničava detektore da sumnjaju na ispravne procese</a:t>
+            </a:r>
+            <a:endParaRPr lang="hr-HR" dirty="0"/>
+          </a:p>
+        </p:txBody>
+      </p:sp>
+    </p:spTree>
+    <p:extLst>
+      <p:ext uri="{BB962C8B-B14F-4D97-AF65-F5344CB8AC3E}">
+        <p14:creationId xmlns:p14="http://schemas.microsoft.com/office/powerpoint/2010/main" val="2113765512"/>
       </p:ext>
     </p:extLst>
   </p:cSld>

</xml_diff>

<commit_message>
Objašnjene klase detektora, mislim da je prezentacija gotova
</commit_message>
<xml_diff>
--- a/Distribuirani procesi(1).pptx
+++ b/Distribuirani procesi(1).pptx
@@ -17,6 +17,10 @@
     <p:sldId id="268" r:id="rId11"/>
     <p:sldId id="269" r:id="rId12"/>
     <p:sldId id="270" r:id="rId13"/>
+    <p:sldId id="271" r:id="rId14"/>
+    <p:sldId id="272" r:id="rId15"/>
+    <p:sldId id="273" r:id="rId16"/>
+    <p:sldId id="274" r:id="rId17"/>
   </p:sldIdLst>
   <p:sldSz cx="12192000" cy="6858000"/>
   <p:notesSz cx="6858000" cy="9144000"/>
@@ -126,7 +130,7 @@
 <file path=ppt/revisionInfo.xml><?xml version="1.0" encoding="utf-8"?>
 <p1510:revInfo xmlns:a="http://schemas.openxmlformats.org/drawingml/2006/main" xmlns:r="http://schemas.openxmlformats.org/officeDocument/2006/relationships" xmlns:p1510="http://schemas.microsoft.com/office/powerpoint/2015/10/main">
   <p1510:revLst>
-    <p1510:client id="{F15753D1-93F3-2B3D-E99A-E7E31308B6C8}" v="664" dt="2026-06-25T21:06:35.496"/>
+    <p1510:client id="{ACC407B5-E6AE-204D-325E-5E02FAF80D84}" v="791" dt="2026-06-29T22:10:33.935"/>
   </p1510:revLst>
 </p1510:revInfo>
 </file>
@@ -632,7 +636,7 @@
             <a:fld id="{B61BEF0D-F0BB-DE4B-95CE-6DB70DBA9567}" type="datetimeFigureOut">
               <a:rPr lang="en-US" dirty="0"/>
               <a:pPr/>
-              <a:t>6/25/2026</a:t>
+              <a:t>6/29/2026</a:t>
             </a:fld>
             <a:endParaRPr lang="en-US" dirty="0"/>
           </a:p>
@@ -925,7 +929,7 @@
             <a:fld id="{B61BEF0D-F0BB-DE4B-95CE-6DB70DBA9567}" type="datetimeFigureOut">
               <a:rPr lang="en-US" dirty="0"/>
               <a:pPr/>
-              <a:t>6/25/2026</a:t>
+              <a:t>6/29/2026</a:t>
             </a:fld>
             <a:endParaRPr lang="en-US" dirty="0"/>
           </a:p>
@@ -1174,7 +1178,7 @@
             <a:fld id="{B61BEF0D-F0BB-DE4B-95CE-6DB70DBA9567}" type="datetimeFigureOut">
               <a:rPr lang="en-US" dirty="0"/>
               <a:pPr/>
-              <a:t>6/25/2026</a:t>
+              <a:t>6/29/2026</a:t>
             </a:fld>
             <a:endParaRPr lang="en-US" dirty="0"/>
           </a:p>
@@ -1715,7 +1719,7 @@
             <a:fld id="{B61BEF0D-F0BB-DE4B-95CE-6DB70DBA9567}" type="datetimeFigureOut">
               <a:rPr lang="en-US" dirty="0"/>
               <a:pPr/>
-              <a:t>6/25/2026</a:t>
+              <a:t>6/29/2026</a:t>
             </a:fld>
             <a:endParaRPr lang="en-US" dirty="0"/>
           </a:p>
@@ -1964,7 +1968,7 @@
             <a:fld id="{B61BEF0D-F0BB-DE4B-95CE-6DB70DBA9567}" type="datetimeFigureOut">
               <a:rPr lang="en-US" dirty="0"/>
               <a:pPr/>
-              <a:t>6/25/2026</a:t>
+              <a:t>6/29/2026</a:t>
             </a:fld>
             <a:endParaRPr lang="en-US" dirty="0"/>
           </a:p>
@@ -2497,7 +2501,7 @@
             <a:fld id="{B61BEF0D-F0BB-DE4B-95CE-6DB70DBA9567}" type="datetimeFigureOut">
               <a:rPr lang="en-US" dirty="0"/>
               <a:pPr/>
-              <a:t>6/25/2026</a:t>
+              <a:t>6/29/2026</a:t>
             </a:fld>
             <a:endParaRPr lang="en-US" dirty="0"/>
           </a:p>
@@ -2795,7 +2799,7 @@
             <a:fld id="{B61BEF0D-F0BB-DE4B-95CE-6DB70DBA9567}" type="datetimeFigureOut">
               <a:rPr lang="en-US" dirty="0"/>
               <a:pPr/>
-              <a:t>6/25/2026</a:t>
+              <a:t>6/29/2026</a:t>
             </a:fld>
             <a:endParaRPr lang="en-US" dirty="0"/>
           </a:p>
@@ -2969,7 +2973,7 @@
             <a:fld id="{B61BEF0D-F0BB-DE4B-95CE-6DB70DBA9567}" type="datetimeFigureOut">
               <a:rPr lang="en-US" dirty="0"/>
               <a:pPr/>
-              <a:t>6/25/2026</a:t>
+              <a:t>6/29/2026</a:t>
             </a:fld>
             <a:endParaRPr lang="en-US" dirty="0"/>
           </a:p>
@@ -3149,7 +3153,7 @@
             <a:fld id="{B61BEF0D-F0BB-DE4B-95CE-6DB70DBA9567}" type="datetimeFigureOut">
               <a:rPr lang="en-US" dirty="0"/>
               <a:pPr/>
-              <a:t>6/25/2026</a:t>
+              <a:t>6/29/2026</a:t>
             </a:fld>
             <a:endParaRPr lang="en-US" dirty="0"/>
           </a:p>
@@ -3319,7 +3323,7 @@
             <a:fld id="{B61BEF0D-F0BB-DE4B-95CE-6DB70DBA9567}" type="datetimeFigureOut">
               <a:rPr lang="en-US" dirty="0"/>
               <a:pPr/>
-              <a:t>6/25/2026</a:t>
+              <a:t>6/29/2026</a:t>
             </a:fld>
             <a:endParaRPr lang="en-US" dirty="0"/>
           </a:p>
@@ -3571,7 +3575,7 @@
             <a:fld id="{B61BEF0D-F0BB-DE4B-95CE-6DB70DBA9567}" type="datetimeFigureOut">
               <a:rPr lang="en-US" dirty="0"/>
               <a:pPr/>
-              <a:t>6/25/2026</a:t>
+              <a:t>6/29/2026</a:t>
             </a:fld>
             <a:endParaRPr lang="en-US" dirty="0"/>
           </a:p>
@@ -3867,7 +3871,7 @@
             <a:fld id="{B61BEF0D-F0BB-DE4B-95CE-6DB70DBA9567}" type="datetimeFigureOut">
               <a:rPr lang="en-US" dirty="0"/>
               <a:pPr/>
-              <a:t>6/25/2026</a:t>
+              <a:t>6/29/2026</a:t>
             </a:fld>
             <a:endParaRPr lang="en-US" dirty="0"/>
           </a:p>
@@ -4308,7 +4312,7 @@
             <a:fld id="{B61BEF0D-F0BB-DE4B-95CE-6DB70DBA9567}" type="datetimeFigureOut">
               <a:rPr lang="en-US" dirty="0"/>
               <a:pPr/>
-              <a:t>6/25/2026</a:t>
+              <a:t>6/29/2026</a:t>
             </a:fld>
             <a:endParaRPr lang="en-US" dirty="0"/>
           </a:p>
@@ -4427,7 +4431,7 @@
             <a:fld id="{B61BEF0D-F0BB-DE4B-95CE-6DB70DBA9567}" type="datetimeFigureOut">
               <a:rPr lang="en-US" dirty="0"/>
               <a:pPr/>
-              <a:t>6/25/2026</a:t>
+              <a:t>6/29/2026</a:t>
             </a:fld>
             <a:endParaRPr lang="en-US" dirty="0"/>
           </a:p>
@@ -4524,7 +4528,7 @@
             <a:fld id="{B61BEF0D-F0BB-DE4B-95CE-6DB70DBA9567}" type="datetimeFigureOut">
               <a:rPr lang="en-US" dirty="0"/>
               <a:pPr/>
-              <a:t>6/25/2026</a:t>
+              <a:t>6/29/2026</a:t>
             </a:fld>
             <a:endParaRPr lang="en-US" dirty="0"/>
           </a:p>
@@ -4807,7 +4811,7 @@
             <a:fld id="{B61BEF0D-F0BB-DE4B-95CE-6DB70DBA9567}" type="datetimeFigureOut">
               <a:rPr lang="en-US" dirty="0"/>
               <a:pPr/>
-              <a:t>6/25/2026</a:t>
+              <a:t>6/29/2026</a:t>
             </a:fld>
             <a:endParaRPr lang="en-US" dirty="0"/>
           </a:p>
@@ -5095,7 +5099,7 @@
             <a:fld id="{B61BEF0D-F0BB-DE4B-95CE-6DB70DBA9567}" type="datetimeFigureOut">
               <a:rPr lang="en-US" dirty="0"/>
               <a:pPr/>
-              <a:t>6/25/2026</a:t>
+              <a:t>6/29/2026</a:t>
             </a:fld>
             <a:endParaRPr lang="en-US" dirty="0"/>
           </a:p>
@@ -5625,7 +5629,7 @@
             <a:fld id="{B61BEF0D-F0BB-DE4B-95CE-6DB70DBA9567}" type="datetimeFigureOut">
               <a:rPr lang="en-US" dirty="0"/>
               <a:pPr/>
-              <a:t>6/25/2026</a:t>
+              <a:t>6/29/2026</a:t>
             </a:fld>
             <a:endParaRPr lang="en-US" dirty="0"/>
           </a:p>
@@ -6930,6 +6934,1424 @@
 </p:sld>
 </file>
 
+<file path=ppt/slides/slide13.xml><?xml version="1.0" encoding="utf-8"?>
+<p:sld xmlns:a="http://schemas.openxmlformats.org/drawingml/2006/main" xmlns:r="http://schemas.openxmlformats.org/officeDocument/2006/relationships" xmlns:p="http://schemas.openxmlformats.org/presentationml/2006/main">
+  <p:cSld>
+    <p:spTree>
+      <p:nvGrpSpPr>
+        <p:cNvPr id="1" name=""/>
+        <p:cNvGrpSpPr/>
+        <p:nvPr/>
+      </p:nvGrpSpPr>
+      <p:grpSpPr>
+        <a:xfrm>
+          <a:off x="0" y="0"/>
+          <a:ext cx="0" cy="0"/>
+          <a:chOff x="0" y="0"/>
+          <a:chExt cx="0" cy="0"/>
+        </a:xfrm>
+      </p:grpSpPr>
+      <p:sp>
+        <p:nvSpPr>
+          <p:cNvPr id="2" name="Naslov 1">
+            <a:extLst>
+              <a:ext uri="{FF2B5EF4-FFF2-40B4-BE49-F238E27FC236}">
+                <a16:creationId xmlns:a16="http://schemas.microsoft.com/office/drawing/2014/main" id="{B7C0A290-30E8-035D-FC80-DD170B3B94AF}"/>
+              </a:ext>
+            </a:extLst>
+          </p:cNvPr>
+          <p:cNvSpPr>
+            <a:spLocks noGrp="1"/>
+          </p:cNvSpPr>
+          <p:nvPr>
+            <p:ph type="title"/>
+          </p:nvPr>
+        </p:nvSpPr>
+        <p:spPr>
+          <a:xfrm>
+            <a:off x="1484311" y="-39914"/>
+            <a:ext cx="10018713" cy="1752599"/>
+          </a:xfrm>
+        </p:spPr>
+        <p:txBody>
+          <a:bodyPr/>
+          <a:lstStyle/>
+          <a:p>
+            <a:r>
+              <a:rPr lang="hr-HR"/>
+              <a:t>Tipovi detektora</a:t>
+            </a:r>
+          </a:p>
+        </p:txBody>
+      </p:sp>
+      <p:sp>
+        <p:nvSpPr>
+          <p:cNvPr id="3" name="Rezervirano mjesto sadržaja 2">
+            <a:extLst>
+              <a:ext uri="{FF2B5EF4-FFF2-40B4-BE49-F238E27FC236}">
+                <a16:creationId xmlns:a16="http://schemas.microsoft.com/office/drawing/2014/main" id="{754DD9EE-E9EF-050A-D916-527065065FE1}"/>
+              </a:ext>
+            </a:extLst>
+          </p:cNvPr>
+          <p:cNvSpPr>
+            <a:spLocks noGrp="1"/>
+          </p:cNvSpPr>
+          <p:nvPr>
+            <p:ph idx="1"/>
+          </p:nvPr>
+        </p:nvSpPr>
+        <p:spPr>
+          <a:xfrm>
+            <a:off x="1484310" y="1201056"/>
+            <a:ext cx="10018713" cy="5504543"/>
+          </a:xfrm>
+        </p:spPr>
+        <p:txBody>
+          <a:bodyPr/>
+          <a:lstStyle/>
+          <a:p>
+            <a:r>
+              <a:rPr lang="hr-HR"/>
+              <a:t>S obzirom na 2 svojstva potpunosti i 4 svojstva konačnosti razlikujemo 8 tipova detektora</a:t>
+            </a:r>
+            <a:endParaRPr lang="sr-Latn-RS"/>
+          </a:p>
+          <a:p>
+            <a:pPr lvl="1">
+              <a:buClr>
+                <a:srgbClr val="1287C3"/>
+              </a:buClr>
+              <a:buFont typeface="Courier New"/>
+              <a:buChar char="o"/>
+            </a:pPr>
+            <a:r>
+              <a:rPr lang="hr-HR"/>
+              <a:t>1. Savršeni detektori kvarova (P) - jaka potpunost i jaka točnost</a:t>
+            </a:r>
+          </a:p>
+          <a:p>
+            <a:pPr lvl="1">
+              <a:buClr>
+                <a:srgbClr val="1287C3"/>
+              </a:buClr>
+              <a:buFont typeface="Courier New"/>
+              <a:buChar char="o"/>
+            </a:pPr>
+            <a:r>
+              <a:rPr lang="hr-HR"/>
+              <a:t>2. Konačno savršeni detektori kvarova </a:t>
+            </a:r>
+            <a:r>
+              <a:rPr lang="hr-HR">
+                <a:ea typeface="+mn-lt"/>
+                <a:cs typeface="+mn-lt"/>
+              </a:rPr>
+              <a:t>(♦P) - jaka potpunost i konačna jaka točnost</a:t>
+            </a:r>
+            <a:endParaRPr lang="hr-HR" dirty="0">
+              <a:ea typeface="+mn-lt"/>
+              <a:cs typeface="+mn-lt"/>
+            </a:endParaRPr>
+          </a:p>
+          <a:p>
+            <a:pPr lvl="1">
+              <a:buClr>
+                <a:srgbClr val="1287C3"/>
+              </a:buClr>
+              <a:buFont typeface="Courier New"/>
+              <a:buChar char="o"/>
+            </a:pPr>
+            <a:r>
+              <a:rPr lang="hr-HR"/>
+              <a:t>3. </a:t>
+            </a:r>
+            <a:r>
+              <a:rPr lang="hr-HR">
+                <a:ea typeface="+mn-lt"/>
+                <a:cs typeface="+mn-lt"/>
+              </a:rPr>
+              <a:t>Jaki detektori  kvarova (S) - jaka potpunost i slaba točnost</a:t>
+            </a:r>
+          </a:p>
+          <a:p>
+            <a:pPr lvl="1">
+              <a:buClr>
+                <a:srgbClr val="1287C3"/>
+              </a:buClr>
+              <a:buFont typeface="Courier New"/>
+              <a:buChar char="o"/>
+            </a:pPr>
+            <a:r>
+              <a:rPr lang="hr-HR"/>
+              <a:t>4. </a:t>
+            </a:r>
+            <a:r>
+              <a:rPr lang="hr-HR">
+                <a:ea typeface="+mn-lt"/>
+                <a:cs typeface="+mn-lt"/>
+              </a:rPr>
+              <a:t>Konačni jaki detektori kvarova (♦S) - jaka potpunost i konačna slaba točnost</a:t>
+            </a:r>
+            <a:endParaRPr lang="hr-HR" dirty="0"/>
+          </a:p>
+          <a:p>
+            <a:pPr lvl="1">
+              <a:buClr>
+                <a:srgbClr val="1287C3"/>
+              </a:buClr>
+              <a:buFont typeface="Courier New"/>
+              <a:buChar char="o"/>
+            </a:pPr>
+            <a:r>
+              <a:rPr lang="hr-HR"/>
+              <a:t>5. </a:t>
+            </a:r>
+            <a:r>
+              <a:rPr lang="hr-HR">
+                <a:ea typeface="+mn-lt"/>
+                <a:cs typeface="+mn-lt"/>
+              </a:rPr>
+              <a:t>Slabi detektori kvarova (W) - slaba potpunost i slaba točnost</a:t>
+            </a:r>
+            <a:endParaRPr lang="hr-HR" dirty="0"/>
+          </a:p>
+          <a:p>
+            <a:pPr lvl="1">
+              <a:buClr>
+                <a:srgbClr val="1287C3"/>
+              </a:buClr>
+              <a:buFont typeface="Courier New"/>
+              <a:buChar char="o"/>
+            </a:pPr>
+            <a:r>
+              <a:rPr lang="hr-HR"/>
+              <a:t>6. </a:t>
+            </a:r>
+            <a:r>
+              <a:rPr lang="hr-HR">
+                <a:ea typeface="+mn-lt"/>
+                <a:cs typeface="+mn-lt"/>
+              </a:rPr>
+              <a:t>Konačno slabi detektori kvarova (♦W) - slaba potpunost i konačna slaba točnost</a:t>
+            </a:r>
+            <a:endParaRPr lang="hr-HR" dirty="0"/>
+          </a:p>
+          <a:p>
+            <a:pPr lvl="1">
+              <a:buClr>
+                <a:srgbClr val="1287C3"/>
+              </a:buClr>
+              <a:buFont typeface="Courier New"/>
+              <a:buChar char="o"/>
+            </a:pPr>
+            <a:r>
+              <a:rPr lang="hr-HR"/>
+              <a:t>7. </a:t>
+            </a:r>
+            <a:r>
+              <a:rPr lang="hr-HR">
+                <a:ea typeface="+mn-lt"/>
+                <a:cs typeface="+mn-lt"/>
+              </a:rPr>
+              <a:t>Detektori kvarova koji zadovoljavaju slabu potpunost i jaku točnost (𝒱 )</a:t>
+            </a:r>
+            <a:endParaRPr lang="hr-HR" dirty="0">
+              <a:ea typeface="+mn-lt"/>
+              <a:cs typeface="+mn-lt"/>
+            </a:endParaRPr>
+          </a:p>
+          <a:p>
+            <a:pPr lvl="1">
+              <a:buClr>
+                <a:srgbClr val="1287C3"/>
+              </a:buClr>
+              <a:buFont typeface="Courier New"/>
+              <a:buChar char="o"/>
+            </a:pPr>
+            <a:r>
+              <a:rPr lang="hr-HR"/>
+              <a:t>8. </a:t>
+            </a:r>
+            <a:r>
+              <a:rPr lang="hr-HR">
+                <a:ea typeface="+mn-lt"/>
+                <a:cs typeface="+mn-lt"/>
+              </a:rPr>
+              <a:t>Detektori kvarova koji zadovoljavaju slabu potpunost i konačnu jaku točnost (♦𝒱 )</a:t>
+            </a:r>
+            <a:endParaRPr lang="hr-HR" dirty="0"/>
+          </a:p>
+        </p:txBody>
+      </p:sp>
+    </p:spTree>
+    <p:extLst>
+      <p:ext uri="{BB962C8B-B14F-4D97-AF65-F5344CB8AC3E}">
+        <p14:creationId xmlns:p14="http://schemas.microsoft.com/office/powerpoint/2010/main" val="1904274027"/>
+      </p:ext>
+    </p:extLst>
+  </p:cSld>
+  <p:clrMapOvr>
+    <a:masterClrMapping/>
+  </p:clrMapOvr>
+</p:sld>
+</file>
+
+<file path=ppt/slides/slide14.xml><?xml version="1.0" encoding="utf-8"?>
+<p:sld xmlns:a="http://schemas.openxmlformats.org/drawingml/2006/main" xmlns:r="http://schemas.openxmlformats.org/officeDocument/2006/relationships" xmlns:p="http://schemas.openxmlformats.org/presentationml/2006/main">
+  <p:cSld>
+    <p:spTree>
+      <p:nvGrpSpPr>
+        <p:cNvPr id="1" name=""/>
+        <p:cNvGrpSpPr/>
+        <p:nvPr/>
+      </p:nvGrpSpPr>
+      <p:grpSpPr>
+        <a:xfrm>
+          <a:off x="0" y="0"/>
+          <a:ext cx="0" cy="0"/>
+          <a:chOff x="0" y="0"/>
+          <a:chExt cx="0" cy="0"/>
+        </a:xfrm>
+      </p:grpSpPr>
+      <p:sp>
+        <p:nvSpPr>
+          <p:cNvPr id="2" name="Naslov 1">
+            <a:extLst>
+              <a:ext uri="{FF2B5EF4-FFF2-40B4-BE49-F238E27FC236}">
+                <a16:creationId xmlns:a16="http://schemas.microsoft.com/office/drawing/2014/main" id="{C9CCFC09-E551-1D6B-8505-380228ED707B}"/>
+              </a:ext>
+            </a:extLst>
+          </p:cNvPr>
+          <p:cNvSpPr>
+            <a:spLocks noGrp="1"/>
+          </p:cNvSpPr>
+          <p:nvPr>
+            <p:ph type="title"/>
+          </p:nvPr>
+        </p:nvSpPr>
+        <p:spPr/>
+        <p:txBody>
+          <a:bodyPr/>
+          <a:lstStyle/>
+          <a:p>
+            <a:r>
+              <a:rPr lang="hr-HR"/>
+              <a:t>Reduciranje detektora</a:t>
+            </a:r>
+          </a:p>
+        </p:txBody>
+      </p:sp>
+      <p:sp>
+        <p:nvSpPr>
+          <p:cNvPr id="3" name="Rezervirano mjesto sadržaja 2">
+            <a:extLst>
+              <a:ext uri="{FF2B5EF4-FFF2-40B4-BE49-F238E27FC236}">
+                <a16:creationId xmlns:a16="http://schemas.microsoft.com/office/drawing/2014/main" id="{939C2166-076E-6FBD-CC98-43AA6264F322}"/>
+              </a:ext>
+            </a:extLst>
+          </p:cNvPr>
+          <p:cNvSpPr>
+            <a:spLocks noGrp="1"/>
+          </p:cNvSpPr>
+          <p:nvPr>
+            <p:ph idx="1"/>
+          </p:nvPr>
+        </p:nvSpPr>
+        <p:spPr/>
+        <p:txBody>
+          <a:bodyPr>
+            <a:normAutofit fontScale="92500" lnSpcReduction="10000"/>
+          </a:bodyPr>
+          <a:lstStyle/>
+          <a:p>
+            <a:pPr marL="342900" indent="-342900"/>
+            <a:r>
+              <a:rPr lang="hr-HR">
+                <a:ea typeface="+mn-lt"/>
+                <a:cs typeface="+mn-lt"/>
+              </a:rPr>
+              <a:t>Neka su D i E neki detektori kvarova </a:t>
+            </a:r>
+            <a:endParaRPr lang="hr-HR" dirty="0">
+              <a:ea typeface="+mn-lt"/>
+              <a:cs typeface="+mn-lt"/>
+            </a:endParaRPr>
+          </a:p>
+          <a:p>
+            <a:pPr>
+              <a:buClr>
+                <a:srgbClr val="1287C3"/>
+              </a:buClr>
+            </a:pPr>
+            <a:r>
+              <a:rPr lang="hr-HR">
+                <a:ea typeface="+mn-lt"/>
+                <a:cs typeface="+mn-lt"/>
+              </a:rPr>
+              <a:t>Ako postoji algoritam T</a:t>
+            </a:r>
+            <a:r>
+              <a:rPr lang="hr-HR" baseline="-25000" dirty="0">
+                <a:ea typeface="+mn-lt"/>
+                <a:cs typeface="+mn-lt"/>
+              </a:rPr>
+              <a:t>D</a:t>
+            </a:r>
+            <a:r>
+              <a:rPr lang="hr-HR" dirty="0">
+                <a:ea typeface="+mn-lt"/>
+                <a:cs typeface="+mn-lt"/>
+              </a:rPr>
+              <a:t> </a:t>
+            </a:r>
+            <a:r>
+              <a:rPr lang="hr-HR" baseline="-25000">
+                <a:ea typeface="+mn-lt"/>
+                <a:cs typeface="+mn-lt"/>
+              </a:rPr>
+              <a:t>→ E </a:t>
+            </a:r>
+            <a:r>
+              <a:rPr lang="hr-HR">
+                <a:ea typeface="+mn-lt"/>
+                <a:cs typeface="+mn-lt"/>
+              </a:rPr>
+              <a:t>koji transformira D u E, kažemo da je E slabiji od D i označavamo ga s D </a:t>
+            </a:r>
+            <a:r>
+              <a:rPr lang="hr-HR" i="1">
+                <a:ea typeface="+mn-lt"/>
+                <a:cs typeface="+mn-lt"/>
+              </a:rPr>
+              <a:t>≈</a:t>
+            </a:r>
+            <a:r>
+              <a:rPr lang="hr-HR">
+                <a:ea typeface="+mn-lt"/>
+                <a:cs typeface="+mn-lt"/>
+              </a:rPr>
+              <a:t> E</a:t>
+            </a:r>
+          </a:p>
+          <a:p>
+            <a:pPr>
+              <a:buClr>
+                <a:srgbClr val="1287C3"/>
+              </a:buClr>
+            </a:pPr>
+            <a:r>
+              <a:rPr lang="hr-HR"/>
+              <a:t>Vrijedi: </a:t>
+            </a:r>
+            <a:r>
+              <a:rPr lang="hr-HR">
+                <a:ea typeface="+mn-lt"/>
+                <a:cs typeface="+mn-lt"/>
+              </a:rPr>
+              <a:t>P </a:t>
+            </a:r>
+            <a:r>
+              <a:rPr lang="hr-HR" i="1">
+                <a:ea typeface="+mn-lt"/>
+                <a:cs typeface="+mn-lt"/>
+              </a:rPr>
+              <a:t>≈</a:t>
+            </a:r>
+            <a:r>
+              <a:rPr lang="hr-HR" dirty="0">
+                <a:ea typeface="+mn-lt"/>
+                <a:cs typeface="+mn-lt"/>
+              </a:rPr>
+              <a:t> </a:t>
+            </a:r>
+            <a:r>
+              <a:rPr lang="hr-HR" sz="2000">
+                <a:ea typeface="+mn-lt"/>
+                <a:cs typeface="+mn-lt"/>
+              </a:rPr>
+              <a:t>𝒱</a:t>
+            </a:r>
+            <a:r>
+              <a:rPr lang="hr-HR">
+                <a:ea typeface="+mn-lt"/>
+                <a:cs typeface="+mn-lt"/>
+              </a:rPr>
+              <a:t>, S </a:t>
+            </a:r>
+            <a:r>
+              <a:rPr lang="hr-HR" i="1">
+                <a:ea typeface="+mn-lt"/>
+                <a:cs typeface="+mn-lt"/>
+              </a:rPr>
+              <a:t>≈</a:t>
+            </a:r>
+            <a:r>
+              <a:rPr lang="hr-HR">
+                <a:ea typeface="+mn-lt"/>
+                <a:cs typeface="+mn-lt"/>
+              </a:rPr>
+              <a:t>W , ♦P </a:t>
+            </a:r>
+            <a:r>
+              <a:rPr lang="hr-HR" i="1">
+                <a:ea typeface="+mn-lt"/>
+                <a:cs typeface="+mn-lt"/>
+              </a:rPr>
+              <a:t>≈</a:t>
+            </a:r>
+            <a:r>
+              <a:rPr lang="hr-HR">
+                <a:ea typeface="+mn-lt"/>
+                <a:cs typeface="+mn-lt"/>
+              </a:rPr>
+              <a:t>♦</a:t>
+            </a:r>
+            <a:r>
+              <a:rPr lang="hr-HR" sz="2000">
+                <a:ea typeface="+mn-lt"/>
+                <a:cs typeface="+mn-lt"/>
+              </a:rPr>
+              <a:t>𝒱 ,</a:t>
+            </a:r>
+            <a:r>
+              <a:rPr lang="hr-HR">
+                <a:ea typeface="+mn-lt"/>
+                <a:cs typeface="+mn-lt"/>
+              </a:rPr>
+              <a:t> ♦S </a:t>
+            </a:r>
+            <a:r>
+              <a:rPr lang="hr-HR" i="1">
+                <a:ea typeface="+mn-lt"/>
+                <a:cs typeface="+mn-lt"/>
+              </a:rPr>
+              <a:t>≈</a:t>
+            </a:r>
+            <a:r>
+              <a:rPr lang="hr-HR" dirty="0">
+                <a:ea typeface="+mn-lt"/>
+                <a:cs typeface="+mn-lt"/>
+              </a:rPr>
+              <a:t>♦W</a:t>
+            </a:r>
+          </a:p>
+          <a:p>
+            <a:pPr>
+              <a:buClr>
+                <a:srgbClr val="1287C3"/>
+              </a:buClr>
+            </a:pPr>
+            <a:r>
+              <a:rPr lang="hr-HR"/>
+              <a:t>Ali može se dokazati da vrijedi i </a:t>
+            </a:r>
+            <a:r>
+              <a:rPr lang="hr-HR" sz="2000">
+                <a:ea typeface="+mn-lt"/>
+                <a:cs typeface="+mn-lt"/>
+              </a:rPr>
+              <a:t>𝒱</a:t>
+            </a:r>
+            <a:r>
+              <a:rPr lang="hr-HR" dirty="0">
+                <a:ea typeface="+mn-lt"/>
+                <a:cs typeface="+mn-lt"/>
+              </a:rPr>
+              <a:t> </a:t>
+            </a:r>
+            <a:r>
+              <a:rPr lang="hr-HR" i="1">
+                <a:ea typeface="+mn-lt"/>
+                <a:cs typeface="+mn-lt"/>
+              </a:rPr>
+              <a:t>≈</a:t>
+            </a:r>
+            <a:r>
+              <a:rPr lang="hr-HR">
+                <a:ea typeface="+mn-lt"/>
+                <a:cs typeface="+mn-lt"/>
+              </a:rPr>
+              <a:t> P , W </a:t>
+            </a:r>
+            <a:r>
+              <a:rPr lang="hr-HR" i="1">
+                <a:ea typeface="+mn-lt"/>
+                <a:cs typeface="+mn-lt"/>
+              </a:rPr>
+              <a:t>≈</a:t>
+            </a:r>
+            <a:r>
+              <a:rPr lang="hr-HR">
+                <a:ea typeface="+mn-lt"/>
+                <a:cs typeface="+mn-lt"/>
+              </a:rPr>
+              <a:t> S , ♦</a:t>
+            </a:r>
+            <a:r>
+              <a:rPr lang="hr-HR" sz="2000">
+                <a:ea typeface="+mn-lt"/>
+                <a:cs typeface="+mn-lt"/>
+              </a:rPr>
+              <a:t>𝒱</a:t>
+            </a:r>
+            <a:r>
+              <a:rPr lang="hr-HR" dirty="0">
+                <a:ea typeface="+mn-lt"/>
+                <a:cs typeface="+mn-lt"/>
+              </a:rPr>
+              <a:t> </a:t>
+            </a:r>
+            <a:r>
+              <a:rPr lang="hr-HR" i="1" dirty="0">
+                <a:ea typeface="+mn-lt"/>
+                <a:cs typeface="+mn-lt"/>
+              </a:rPr>
+              <a:t>≈</a:t>
+            </a:r>
+            <a:r>
+              <a:rPr lang="hr-HR">
+                <a:ea typeface="+mn-lt"/>
+                <a:cs typeface="+mn-lt"/>
+              </a:rPr>
+              <a:t> ♦P , ♦W </a:t>
+            </a:r>
+            <a:r>
+              <a:rPr lang="hr-HR" i="1" dirty="0">
+                <a:ea typeface="+mn-lt"/>
+                <a:cs typeface="+mn-lt"/>
+              </a:rPr>
+              <a:t>≈</a:t>
+            </a:r>
+            <a:r>
+              <a:rPr lang="hr-HR">
+                <a:ea typeface="+mn-lt"/>
+                <a:cs typeface="+mn-lt"/>
+              </a:rPr>
+              <a:t> ♦S</a:t>
+            </a:r>
+          </a:p>
+          <a:p>
+            <a:pPr>
+              <a:buClr>
+                <a:srgbClr val="1287C3"/>
+              </a:buClr>
+            </a:pPr>
+            <a:r>
+              <a:rPr lang="hr-HR"/>
+              <a:t>Tako da na kraju imamo </a:t>
+            </a:r>
+            <a:r>
+              <a:rPr lang="hr-HR">
+                <a:ea typeface="+mn-lt"/>
+                <a:cs typeface="+mn-lt"/>
+              </a:rPr>
+              <a:t>P ≡ </a:t>
+            </a:r>
+            <a:r>
+              <a:rPr lang="hr-HR" sz="2000">
+                <a:ea typeface="+mn-lt"/>
+                <a:cs typeface="+mn-lt"/>
+              </a:rPr>
+              <a:t>𝒱 ,</a:t>
+            </a:r>
+            <a:r>
+              <a:rPr lang="hr-HR">
+                <a:ea typeface="+mn-lt"/>
+                <a:cs typeface="+mn-lt"/>
+              </a:rPr>
+              <a:t> S ≡ W , ♦P ≡ ♦</a:t>
+            </a:r>
+            <a:r>
+              <a:rPr lang="hr-HR" sz="2000">
+                <a:ea typeface="+mn-lt"/>
+                <a:cs typeface="+mn-lt"/>
+              </a:rPr>
+              <a:t>𝒱</a:t>
+            </a:r>
+            <a:r>
+              <a:rPr lang="hr-HR">
+                <a:ea typeface="+mn-lt"/>
+                <a:cs typeface="+mn-lt"/>
+              </a:rPr>
+              <a:t> , ♦S ≡ ♦W</a:t>
+            </a:r>
+            <a:endParaRPr lang="hr-HR" dirty="0">
+              <a:ea typeface="+mn-lt"/>
+              <a:cs typeface="+mn-lt"/>
+            </a:endParaRPr>
+          </a:p>
+          <a:p>
+            <a:pPr>
+              <a:buClr>
+                <a:srgbClr val="1287C3"/>
+              </a:buClr>
+            </a:pPr>
+            <a:r>
+              <a:rPr lang="hr-HR"/>
+              <a:t>Također vrijedi i </a:t>
+            </a:r>
+            <a:r>
+              <a:rPr lang="hr-HR">
+                <a:ea typeface="+mn-lt"/>
+                <a:cs typeface="+mn-lt"/>
+              </a:rPr>
+              <a:t>P </a:t>
+            </a:r>
+            <a:r>
+              <a:rPr lang="hr-HR" i="1">
+                <a:ea typeface="+mn-lt"/>
+                <a:cs typeface="+mn-lt"/>
+              </a:rPr>
+              <a:t>≈</a:t>
+            </a:r>
+            <a:r>
+              <a:rPr lang="hr-HR">
+                <a:ea typeface="+mn-lt"/>
+                <a:cs typeface="+mn-lt"/>
+              </a:rPr>
+              <a:t> S i ♦P ≈ ♦S</a:t>
+            </a:r>
+          </a:p>
+          <a:p>
+            <a:pPr>
+              <a:buClr>
+                <a:srgbClr val="1287C3"/>
+              </a:buClr>
+            </a:pPr>
+            <a:endParaRPr lang="hr-HR" dirty="0"/>
+          </a:p>
+        </p:txBody>
+      </p:sp>
+      <p:cxnSp>
+        <p:nvCxnSpPr>
+          <p:cNvPr id="5" name="Ravni poveznik sa strelicom 4">
+            <a:extLst>
+              <a:ext uri="{FF2B5EF4-FFF2-40B4-BE49-F238E27FC236}">
+                <a16:creationId xmlns:a16="http://schemas.microsoft.com/office/drawing/2014/main" id="{178EC928-84C6-EB96-B614-B48966578E1E}"/>
+              </a:ext>
+            </a:extLst>
+          </p:cNvPr>
+          <p:cNvCxnSpPr>
+            <a:cxnSpLocks/>
+          </p:cNvCxnSpPr>
+          <p:nvPr/>
+        </p:nvCxnSpPr>
+        <p:spPr>
+          <a:xfrm>
+            <a:off x="4844470" y="803233"/>
+            <a:ext cx="137161385" cy="12205"/>
+          </a:xfrm>
+          <a:prstGeom prst="straightConnector1">
+            <a:avLst/>
+          </a:prstGeom>
+        </p:spPr>
+        <p:style>
+          <a:lnRef idx="1">
+            <a:schemeClr val="accent1"/>
+          </a:lnRef>
+          <a:fillRef idx="0">
+            <a:schemeClr val="accent1"/>
+          </a:fillRef>
+          <a:effectRef idx="0">
+            <a:schemeClr val="accent1"/>
+          </a:effectRef>
+          <a:fontRef idx="minor">
+            <a:schemeClr val="tx1"/>
+          </a:fontRef>
+        </p:style>
+      </p:cxnSp>
+    </p:spTree>
+    <p:extLst>
+      <p:ext uri="{BB962C8B-B14F-4D97-AF65-F5344CB8AC3E}">
+        <p14:creationId xmlns:p14="http://schemas.microsoft.com/office/powerpoint/2010/main" val="4063283827"/>
+      </p:ext>
+    </p:extLst>
+  </p:cSld>
+  <p:clrMapOvr>
+    <a:masterClrMapping/>
+  </p:clrMapOvr>
+</p:sld>
+</file>
+
+<file path=ppt/slides/slide15.xml><?xml version="1.0" encoding="utf-8"?>
+<p:sld xmlns:a="http://schemas.openxmlformats.org/drawingml/2006/main" xmlns:r="http://schemas.openxmlformats.org/officeDocument/2006/relationships" xmlns:p="http://schemas.openxmlformats.org/presentationml/2006/main">
+  <p:cSld>
+    <p:spTree>
+      <p:nvGrpSpPr>
+        <p:cNvPr id="1" name=""/>
+        <p:cNvGrpSpPr/>
+        <p:nvPr/>
+      </p:nvGrpSpPr>
+      <p:grpSpPr>
+        <a:xfrm>
+          <a:off x="0" y="0"/>
+          <a:ext cx="0" cy="0"/>
+          <a:chOff x="0" y="0"/>
+          <a:chExt cx="0" cy="0"/>
+        </a:xfrm>
+      </p:grpSpPr>
+      <p:sp>
+        <p:nvSpPr>
+          <p:cNvPr id="2" name="Naslov 1">
+            <a:extLst>
+              <a:ext uri="{FF2B5EF4-FFF2-40B4-BE49-F238E27FC236}">
+                <a16:creationId xmlns:a16="http://schemas.microsoft.com/office/drawing/2014/main" id="{2BC3E0E9-7041-4600-2A2A-33C0056DA6B2}"/>
+              </a:ext>
+            </a:extLst>
+          </p:cNvPr>
+          <p:cNvSpPr>
+            <a:spLocks noGrp="1"/>
+          </p:cNvSpPr>
+          <p:nvPr>
+            <p:ph type="title"/>
+          </p:nvPr>
+        </p:nvSpPr>
+        <p:spPr/>
+        <p:txBody>
+          <a:bodyPr/>
+          <a:lstStyle/>
+          <a:p>
+            <a:r>
+              <a:rPr lang="hr-HR"/>
+              <a:t>Reduciranje detektora</a:t>
+            </a:r>
+          </a:p>
+        </p:txBody>
+      </p:sp>
+      <p:cxnSp>
+        <p:nvCxnSpPr>
+          <p:cNvPr id="4" name="Ravni poveznik sa strelicom 3">
+            <a:extLst>
+              <a:ext uri="{FF2B5EF4-FFF2-40B4-BE49-F238E27FC236}">
+                <a16:creationId xmlns:a16="http://schemas.microsoft.com/office/drawing/2014/main" id="{02431606-3E17-D3AB-60CA-CAD2609E93A1}"/>
+              </a:ext>
+            </a:extLst>
+          </p:cNvPr>
+          <p:cNvCxnSpPr/>
+          <p:nvPr/>
+        </p:nvCxnSpPr>
+        <p:spPr>
+          <a:xfrm flipH="1">
+            <a:off x="3496156" y="3278909"/>
+            <a:ext cx="481940" cy="984513"/>
+          </a:xfrm>
+          <a:prstGeom prst="straightConnector1">
+            <a:avLst/>
+          </a:prstGeom>
+          <a:ln>
+            <a:solidFill>
+              <a:schemeClr val="tx1"/>
+            </a:solidFill>
+          </a:ln>
+        </p:spPr>
+        <p:style>
+          <a:lnRef idx="1">
+            <a:schemeClr val="accent1"/>
+          </a:lnRef>
+          <a:fillRef idx="0">
+            <a:schemeClr val="accent1"/>
+          </a:fillRef>
+          <a:effectRef idx="0">
+            <a:schemeClr val="accent1"/>
+          </a:effectRef>
+          <a:fontRef idx="minor">
+            <a:schemeClr val="tx1"/>
+          </a:fontRef>
+        </p:style>
+      </p:cxnSp>
+      <p:cxnSp>
+        <p:nvCxnSpPr>
+          <p:cNvPr id="5" name="Ravni poveznik sa strelicom 4">
+            <a:extLst>
+              <a:ext uri="{FF2B5EF4-FFF2-40B4-BE49-F238E27FC236}">
+                <a16:creationId xmlns:a16="http://schemas.microsoft.com/office/drawing/2014/main" id="{59198A8C-86AD-6191-BDE7-752463B5534C}"/>
+              </a:ext>
+            </a:extLst>
+          </p:cNvPr>
+          <p:cNvCxnSpPr/>
+          <p:nvPr/>
+        </p:nvCxnSpPr>
+        <p:spPr>
+          <a:xfrm>
+            <a:off x="4011265" y="3274654"/>
+            <a:ext cx="463593" cy="981125"/>
+          </a:xfrm>
+          <a:prstGeom prst="straightConnector1">
+            <a:avLst/>
+          </a:prstGeom>
+          <a:ln>
+            <a:solidFill>
+              <a:schemeClr val="tx1"/>
+            </a:solidFill>
+          </a:ln>
+        </p:spPr>
+        <p:style>
+          <a:lnRef idx="1">
+            <a:schemeClr val="accent1"/>
+          </a:lnRef>
+          <a:fillRef idx="0">
+            <a:schemeClr val="accent1"/>
+          </a:fillRef>
+          <a:effectRef idx="0">
+            <a:schemeClr val="accent1"/>
+          </a:effectRef>
+          <a:fontRef idx="minor">
+            <a:schemeClr val="tx1"/>
+          </a:fontRef>
+        </p:style>
+      </p:cxnSp>
+      <p:cxnSp>
+        <p:nvCxnSpPr>
+          <p:cNvPr id="6" name="Ravni poveznik sa strelicom 5">
+            <a:extLst>
+              <a:ext uri="{FF2B5EF4-FFF2-40B4-BE49-F238E27FC236}">
+                <a16:creationId xmlns:a16="http://schemas.microsoft.com/office/drawing/2014/main" id="{8370DCAA-C804-2210-C7F4-9F602408D8D4}"/>
+              </a:ext>
+            </a:extLst>
+          </p:cNvPr>
+          <p:cNvCxnSpPr>
+            <a:cxnSpLocks/>
+          </p:cNvCxnSpPr>
+          <p:nvPr/>
+        </p:nvCxnSpPr>
+        <p:spPr>
+          <a:xfrm flipH="1">
+            <a:off x="7930269" y="3206337"/>
+            <a:ext cx="481940" cy="984513"/>
+          </a:xfrm>
+          <a:prstGeom prst="straightConnector1">
+            <a:avLst/>
+          </a:prstGeom>
+          <a:ln>
+            <a:solidFill>
+              <a:schemeClr val="tx1"/>
+            </a:solidFill>
+          </a:ln>
+        </p:spPr>
+        <p:style>
+          <a:lnRef idx="1">
+            <a:schemeClr val="accent1"/>
+          </a:lnRef>
+          <a:fillRef idx="0">
+            <a:schemeClr val="accent1"/>
+          </a:fillRef>
+          <a:effectRef idx="0">
+            <a:schemeClr val="accent1"/>
+          </a:effectRef>
+          <a:fontRef idx="minor">
+            <a:schemeClr val="tx1"/>
+          </a:fontRef>
+        </p:style>
+      </p:cxnSp>
+      <p:cxnSp>
+        <p:nvCxnSpPr>
+          <p:cNvPr id="7" name="Ravni poveznik sa strelicom 6">
+            <a:extLst>
+              <a:ext uri="{FF2B5EF4-FFF2-40B4-BE49-F238E27FC236}">
+                <a16:creationId xmlns:a16="http://schemas.microsoft.com/office/drawing/2014/main" id="{29944AF3-A40A-A352-6D09-DA6307FA2637}"/>
+              </a:ext>
+            </a:extLst>
+          </p:cNvPr>
+          <p:cNvCxnSpPr>
+            <a:cxnSpLocks/>
+          </p:cNvCxnSpPr>
+          <p:nvPr/>
+        </p:nvCxnSpPr>
+        <p:spPr>
+          <a:xfrm>
+            <a:off x="8445378" y="3202082"/>
+            <a:ext cx="463593" cy="981125"/>
+          </a:xfrm>
+          <a:prstGeom prst="straightConnector1">
+            <a:avLst/>
+          </a:prstGeom>
+          <a:ln>
+            <a:solidFill>
+              <a:schemeClr val="tx1"/>
+            </a:solidFill>
+          </a:ln>
+        </p:spPr>
+        <p:style>
+          <a:lnRef idx="1">
+            <a:schemeClr val="accent1"/>
+          </a:lnRef>
+          <a:fillRef idx="0">
+            <a:schemeClr val="accent1"/>
+          </a:fillRef>
+          <a:effectRef idx="0">
+            <a:schemeClr val="accent1"/>
+          </a:effectRef>
+          <a:fontRef idx="minor">
+            <a:schemeClr val="tx1"/>
+          </a:fontRef>
+        </p:style>
+      </p:cxnSp>
+      <p:sp>
+        <p:nvSpPr>
+          <p:cNvPr id="8" name="TekstniOkvir 7">
+            <a:extLst>
+              <a:ext uri="{FF2B5EF4-FFF2-40B4-BE49-F238E27FC236}">
+                <a16:creationId xmlns:a16="http://schemas.microsoft.com/office/drawing/2014/main" id="{239D7CC8-347D-2845-44B9-09195F26A002}"/>
+              </a:ext>
+            </a:extLst>
+          </p:cNvPr>
+          <p:cNvSpPr txBox="1"/>
+          <p:nvPr/>
+        </p:nvSpPr>
+        <p:spPr>
+          <a:xfrm>
+            <a:off x="3890693" y="2886295"/>
+            <a:ext cx="936376" cy="430887"/>
+          </a:xfrm>
+          <a:prstGeom prst="rect">
+            <a:avLst/>
+          </a:prstGeom>
+          <a:noFill/>
+        </p:spPr>
+        <p:txBody>
+          <a:bodyPr rot="0" spcFirstLastPara="0" vertOverflow="overflow" horzOverflow="overflow" vert="horz" wrap="square" lIns="91440" tIns="45720" rIns="91440" bIns="45720" numCol="1" spcCol="0" rtlCol="0" fromWordArt="0" anchor="t" anchorCtr="0" forceAA="0" compatLnSpc="1">
+            <a:prstTxWarp prst="textNoShape">
+              <a:avLst/>
+            </a:prstTxWarp>
+            <a:spAutoFit/>
+          </a:bodyPr>
+          <a:lstStyle/>
+          <a:p>
+            <a:pPr algn="l"/>
+            <a:r>
+              <a:rPr lang="hr-HR" sz="2200"/>
+              <a:t>S</a:t>
+            </a:r>
+          </a:p>
+        </p:txBody>
+      </p:sp>
+      <p:sp>
+        <p:nvSpPr>
+          <p:cNvPr id="10" name="TekstniOkvir 9">
+            <a:extLst>
+              <a:ext uri="{FF2B5EF4-FFF2-40B4-BE49-F238E27FC236}">
+                <a16:creationId xmlns:a16="http://schemas.microsoft.com/office/drawing/2014/main" id="{91514064-3730-D3CA-C48E-3BE9852D2A74}"/>
+              </a:ext>
+            </a:extLst>
+          </p:cNvPr>
+          <p:cNvSpPr txBox="1"/>
+          <p:nvPr/>
+        </p:nvSpPr>
+        <p:spPr>
+          <a:xfrm>
+            <a:off x="8166538" y="2755666"/>
+            <a:ext cx="1117918" cy="430887"/>
+          </a:xfrm>
+          <a:prstGeom prst="rect">
+            <a:avLst/>
+          </a:prstGeom>
+          <a:noFill/>
+        </p:spPr>
+        <p:txBody>
+          <a:bodyPr rot="0" spcFirstLastPara="0" vertOverflow="overflow" horzOverflow="overflow" vert="horz" wrap="square" lIns="91440" tIns="45720" rIns="91440" bIns="45720" numCol="1" spcCol="0" rtlCol="0" fromWordArt="0" anchor="t" anchorCtr="0" forceAA="0" compatLnSpc="1">
+            <a:prstTxWarp prst="textNoShape">
+              <a:avLst/>
+            </a:prstTxWarp>
+            <a:spAutoFit/>
+          </a:bodyPr>
+          <a:lstStyle/>
+          <a:p>
+            <a:pPr algn="l"/>
+            <a:r>
+              <a:rPr lang="hr-HR" sz="2200"/>
+              <a:t>♦S</a:t>
+            </a:r>
+            <a:endParaRPr lang="sr-Latn-RS"/>
+          </a:p>
+        </p:txBody>
+      </p:sp>
+      <p:sp>
+        <p:nvSpPr>
+          <p:cNvPr id="11" name="TekstniOkvir 10">
+            <a:extLst>
+              <a:ext uri="{FF2B5EF4-FFF2-40B4-BE49-F238E27FC236}">
+                <a16:creationId xmlns:a16="http://schemas.microsoft.com/office/drawing/2014/main" id="{E2399141-B708-820C-F2E3-A30C969F0AF2}"/>
+              </a:ext>
+            </a:extLst>
+          </p:cNvPr>
+          <p:cNvSpPr txBox="1"/>
+          <p:nvPr/>
+        </p:nvSpPr>
+        <p:spPr>
+          <a:xfrm>
+            <a:off x="3248083" y="4303553"/>
+            <a:ext cx="2226282" cy="430887"/>
+          </a:xfrm>
+          <a:prstGeom prst="rect">
+            <a:avLst/>
+          </a:prstGeom>
+          <a:noFill/>
+        </p:spPr>
+        <p:txBody>
+          <a:bodyPr rot="0" spcFirstLastPara="0" vertOverflow="overflow" horzOverflow="overflow" vert="horz" wrap="square" lIns="91440" tIns="45720" rIns="91440" bIns="45720" numCol="1" spcCol="0" rtlCol="0" fromWordArt="0" anchor="t" anchorCtr="0" forceAA="0" compatLnSpc="1">
+            <a:prstTxWarp prst="textNoShape">
+              <a:avLst/>
+            </a:prstTxWarp>
+            <a:spAutoFit/>
+          </a:bodyPr>
+          <a:lstStyle/>
+          <a:p>
+            <a:r>
+              <a:rPr lang="hr-HR" sz="2200"/>
+              <a:t>W                P</a:t>
+            </a:r>
+            <a:endParaRPr lang="sr-Latn-RS" sz="2200"/>
+          </a:p>
+        </p:txBody>
+      </p:sp>
+      <p:cxnSp>
+        <p:nvCxnSpPr>
+          <p:cNvPr id="12" name="Ravni poveznik sa strelicom 11">
+            <a:extLst>
+              <a:ext uri="{FF2B5EF4-FFF2-40B4-BE49-F238E27FC236}">
+                <a16:creationId xmlns:a16="http://schemas.microsoft.com/office/drawing/2014/main" id="{5B0B035B-A86C-22E3-F5B9-30229D6B27F9}"/>
+              </a:ext>
+            </a:extLst>
+          </p:cNvPr>
+          <p:cNvCxnSpPr/>
+          <p:nvPr/>
+        </p:nvCxnSpPr>
+        <p:spPr>
+          <a:xfrm>
+            <a:off x="4579234" y="4805730"/>
+            <a:ext cx="19109" cy="745278"/>
+          </a:xfrm>
+          <a:prstGeom prst="straightConnector1">
+            <a:avLst/>
+          </a:prstGeom>
+          <a:ln>
+            <a:solidFill>
+              <a:schemeClr val="tx1"/>
+            </a:solidFill>
+          </a:ln>
+        </p:spPr>
+        <p:style>
+          <a:lnRef idx="1">
+            <a:schemeClr val="accent1"/>
+          </a:lnRef>
+          <a:fillRef idx="0">
+            <a:schemeClr val="accent1"/>
+          </a:fillRef>
+          <a:effectRef idx="0">
+            <a:schemeClr val="accent1"/>
+          </a:effectRef>
+          <a:fontRef idx="minor">
+            <a:schemeClr val="tx1"/>
+          </a:fontRef>
+        </p:style>
+      </p:cxnSp>
+      <p:cxnSp>
+        <p:nvCxnSpPr>
+          <p:cNvPr id="13" name="Ravni poveznik sa strelicom 12">
+            <a:extLst>
+              <a:ext uri="{FF2B5EF4-FFF2-40B4-BE49-F238E27FC236}">
+                <a16:creationId xmlns:a16="http://schemas.microsoft.com/office/drawing/2014/main" id="{B294B84E-974A-D6E6-D1F2-95E4BFAFBF6D}"/>
+              </a:ext>
+            </a:extLst>
+          </p:cNvPr>
+          <p:cNvCxnSpPr>
+            <a:cxnSpLocks/>
+          </p:cNvCxnSpPr>
+          <p:nvPr/>
+        </p:nvCxnSpPr>
+        <p:spPr>
+          <a:xfrm>
+            <a:off x="8977062" y="4733158"/>
+            <a:ext cx="19109" cy="745278"/>
+          </a:xfrm>
+          <a:prstGeom prst="straightConnector1">
+            <a:avLst/>
+          </a:prstGeom>
+          <a:ln>
+            <a:solidFill>
+              <a:schemeClr val="tx1"/>
+            </a:solidFill>
+          </a:ln>
+        </p:spPr>
+        <p:style>
+          <a:lnRef idx="1">
+            <a:schemeClr val="accent1"/>
+          </a:lnRef>
+          <a:fillRef idx="0">
+            <a:schemeClr val="accent1"/>
+          </a:fillRef>
+          <a:effectRef idx="0">
+            <a:schemeClr val="accent1"/>
+          </a:effectRef>
+          <a:fontRef idx="minor">
+            <a:schemeClr val="tx1"/>
+          </a:fontRef>
+        </p:style>
+      </p:cxnSp>
+      <p:sp>
+        <p:nvSpPr>
+          <p:cNvPr id="14" name="TekstniOkvir 13">
+            <a:extLst>
+              <a:ext uri="{FF2B5EF4-FFF2-40B4-BE49-F238E27FC236}">
+                <a16:creationId xmlns:a16="http://schemas.microsoft.com/office/drawing/2014/main" id="{52A00F23-4FC2-2732-7D99-A878A6F59034}"/>
+              </a:ext>
+            </a:extLst>
+          </p:cNvPr>
+          <p:cNvSpPr txBox="1"/>
+          <p:nvPr/>
+        </p:nvSpPr>
+        <p:spPr>
+          <a:xfrm>
+            <a:off x="7595657" y="4282509"/>
+            <a:ext cx="1988752" cy="430887"/>
+          </a:xfrm>
+          <a:prstGeom prst="rect">
+            <a:avLst/>
+          </a:prstGeom>
+          <a:noFill/>
+        </p:spPr>
+        <p:txBody>
+          <a:bodyPr rot="0" spcFirstLastPara="0" vertOverflow="overflow" horzOverflow="overflow" vert="horz" wrap="square" lIns="91440" tIns="45720" rIns="91440" bIns="45720" numCol="1" spcCol="0" rtlCol="0" fromWordArt="0" anchor="t" anchorCtr="0" forceAA="0" compatLnSpc="1">
+            <a:prstTxWarp prst="textNoShape">
+              <a:avLst/>
+            </a:prstTxWarp>
+            <a:spAutoFit/>
+          </a:bodyPr>
+          <a:lstStyle/>
+          <a:p>
+            <a:r>
+              <a:rPr lang="hr-HR" sz="2200" dirty="0"/>
+              <a:t>♦W</a:t>
+            </a:r>
+            <a:r>
+              <a:rPr lang="hr-HR" sz="1900" dirty="0"/>
+              <a:t>                 </a:t>
+            </a:r>
+            <a:r>
+              <a:rPr lang="hr-HR" sz="2200"/>
+              <a:t>♦P</a:t>
+            </a:r>
+            <a:endParaRPr lang="hr-HR" sz="1900"/>
+          </a:p>
+        </p:txBody>
+      </p:sp>
+      <p:sp>
+        <p:nvSpPr>
+          <p:cNvPr id="15" name="TekstniOkvir 14">
+            <a:extLst>
+              <a:ext uri="{FF2B5EF4-FFF2-40B4-BE49-F238E27FC236}">
+                <a16:creationId xmlns:a16="http://schemas.microsoft.com/office/drawing/2014/main" id="{2AD47761-3A77-99F4-9057-0828FF0A01DE}"/>
+              </a:ext>
+            </a:extLst>
+          </p:cNvPr>
+          <p:cNvSpPr txBox="1"/>
+          <p:nvPr/>
+        </p:nvSpPr>
+        <p:spPr>
+          <a:xfrm>
+            <a:off x="4412684" y="5672560"/>
+            <a:ext cx="802608" cy="384721"/>
+          </a:xfrm>
+          <a:prstGeom prst="rect">
+            <a:avLst/>
+          </a:prstGeom>
+          <a:noFill/>
+        </p:spPr>
+        <p:txBody>
+          <a:bodyPr rot="0" spcFirstLastPara="0" vertOverflow="overflow" horzOverflow="overflow" vert="horz" wrap="square" lIns="91440" tIns="45720" rIns="91440" bIns="45720" numCol="1" spcCol="0" rtlCol="0" fromWordArt="0" anchor="t" anchorCtr="0" forceAA="0" compatLnSpc="1">
+            <a:prstTxWarp prst="textNoShape">
+              <a:avLst/>
+            </a:prstTxWarp>
+            <a:spAutoFit/>
+          </a:bodyPr>
+          <a:lstStyle/>
+          <a:p>
+            <a:pPr algn="l"/>
+            <a:r>
+              <a:rPr lang="hr-HR" sz="1900"/>
+              <a:t>𝒱</a:t>
+            </a:r>
+            <a:endParaRPr lang="sr-Latn-RS"/>
+          </a:p>
+        </p:txBody>
+      </p:sp>
+      <p:sp>
+        <p:nvSpPr>
+          <p:cNvPr id="16" name="TekstniOkvir 15">
+            <a:extLst>
+              <a:ext uri="{FF2B5EF4-FFF2-40B4-BE49-F238E27FC236}">
+                <a16:creationId xmlns:a16="http://schemas.microsoft.com/office/drawing/2014/main" id="{429ABD32-F04B-55E7-B6CB-6831C4A71B3F}"/>
+              </a:ext>
+            </a:extLst>
+          </p:cNvPr>
+          <p:cNvSpPr txBox="1"/>
+          <p:nvPr/>
+        </p:nvSpPr>
+        <p:spPr>
+          <a:xfrm>
+            <a:off x="8725315" y="5670626"/>
+            <a:ext cx="668840" cy="384721"/>
+          </a:xfrm>
+          <a:prstGeom prst="rect">
+            <a:avLst/>
+          </a:prstGeom>
+          <a:noFill/>
+        </p:spPr>
+        <p:txBody>
+          <a:bodyPr rot="0" spcFirstLastPara="0" vertOverflow="overflow" horzOverflow="overflow" vert="horz" wrap="square" lIns="91440" tIns="45720" rIns="91440" bIns="45720" numCol="1" spcCol="0" rtlCol="0" fromWordArt="0" anchor="t" anchorCtr="0" forceAA="0" compatLnSpc="1">
+            <a:prstTxWarp prst="textNoShape">
+              <a:avLst/>
+            </a:prstTxWarp>
+            <a:spAutoFit/>
+          </a:bodyPr>
+          <a:lstStyle/>
+          <a:p>
+            <a:pPr algn="l"/>
+            <a:r>
+              <a:rPr lang="hr-HR"/>
+              <a:t>♦</a:t>
+            </a:r>
+            <a:r>
+              <a:rPr lang="hr-HR" sz="1900"/>
+              <a:t>𝒱</a:t>
+            </a:r>
+            <a:endParaRPr lang="sr-Latn-RS"/>
+          </a:p>
+        </p:txBody>
+      </p:sp>
+    </p:spTree>
+    <p:extLst>
+      <p:ext uri="{BB962C8B-B14F-4D97-AF65-F5344CB8AC3E}">
+        <p14:creationId xmlns:p14="http://schemas.microsoft.com/office/powerpoint/2010/main" val="1942318479"/>
+      </p:ext>
+    </p:extLst>
+  </p:cSld>
+  <p:clrMapOvr>
+    <a:masterClrMapping/>
+  </p:clrMapOvr>
+</p:sld>
+</file>
+
+<file path=ppt/slides/slide16.xml><?xml version="1.0" encoding="utf-8"?>
+<p:sld xmlns:a="http://schemas.openxmlformats.org/drawingml/2006/main" xmlns:r="http://schemas.openxmlformats.org/officeDocument/2006/relationships" xmlns:p="http://schemas.openxmlformats.org/presentationml/2006/main">
+  <p:cSld>
+    <p:spTree>
+      <p:nvGrpSpPr>
+        <p:cNvPr id="1" name=""/>
+        <p:cNvGrpSpPr/>
+        <p:nvPr/>
+      </p:nvGrpSpPr>
+      <p:grpSpPr>
+        <a:xfrm>
+          <a:off x="0" y="0"/>
+          <a:ext cx="0" cy="0"/>
+          <a:chOff x="0" y="0"/>
+          <a:chExt cx="0" cy="0"/>
+        </a:xfrm>
+      </p:grpSpPr>
+      <p:sp>
+        <p:nvSpPr>
+          <p:cNvPr id="2" name="Naslov 1">
+            <a:extLst>
+              <a:ext uri="{FF2B5EF4-FFF2-40B4-BE49-F238E27FC236}">
+                <a16:creationId xmlns:a16="http://schemas.microsoft.com/office/drawing/2014/main" id="{8819CB99-2AB4-B3A5-B500-73B446B60427}"/>
+              </a:ext>
+            </a:extLst>
+          </p:cNvPr>
+          <p:cNvSpPr>
+            <a:spLocks noGrp="1"/>
+          </p:cNvSpPr>
+          <p:nvPr>
+            <p:ph type="title"/>
+          </p:nvPr>
+        </p:nvSpPr>
+        <p:spPr/>
+        <p:txBody>
+          <a:bodyPr/>
+          <a:lstStyle/>
+          <a:p>
+            <a:r>
+              <a:rPr lang="hr-HR"/>
+              <a:t>Algoritam za konsenzus</a:t>
+            </a:r>
+          </a:p>
+        </p:txBody>
+      </p:sp>
+      <p:sp>
+        <p:nvSpPr>
+          <p:cNvPr id="3" name="Rezervirano mjesto sadržaja 2">
+            <a:extLst>
+              <a:ext uri="{FF2B5EF4-FFF2-40B4-BE49-F238E27FC236}">
+                <a16:creationId xmlns:a16="http://schemas.microsoft.com/office/drawing/2014/main" id="{71D8EE8D-50BA-FF10-0709-DCC8B0B10E91}"/>
+              </a:ext>
+            </a:extLst>
+          </p:cNvPr>
+          <p:cNvSpPr>
+            <a:spLocks noGrp="1"/>
+          </p:cNvSpPr>
+          <p:nvPr>
+            <p:ph idx="1"/>
+          </p:nvPr>
+        </p:nvSpPr>
+        <p:spPr/>
+        <p:txBody>
+          <a:bodyPr/>
+          <a:lstStyle/>
+          <a:p>
+            <a:r>
+              <a:rPr lang="hr-HR"/>
+              <a:t>Pošto su svi detektori reducibilni na detektore S i </a:t>
+            </a:r>
+            <a:r>
+              <a:rPr lang="hr-HR" sz="2200"/>
+              <a:t>♦S, konsenzus moramo rješiti samo za te dvije klase detektora</a:t>
+            </a:r>
+          </a:p>
+          <a:p>
+            <a:pPr>
+              <a:buClr>
+                <a:srgbClr val="1287C3"/>
+              </a:buClr>
+            </a:pPr>
+            <a:r>
+              <a:rPr lang="hr-HR" sz="2200">
+                <a:ea typeface="+mn-lt"/>
+                <a:cs typeface="+mn-lt"/>
+              </a:rPr>
+              <a:t>Konsenzusni algoritam koji koristi S može tolerirati bilo koji broj kvarova procesa</a:t>
+            </a:r>
+            <a:endParaRPr lang="hr-HR" sz="2200" dirty="0"/>
+          </a:p>
+          <a:p>
+            <a:pPr>
+              <a:buClr>
+                <a:srgbClr val="1287C3"/>
+              </a:buClr>
+            </a:pPr>
+            <a:r>
+              <a:rPr lang="hr-HR" sz="2200">
+                <a:ea typeface="+mn-lt"/>
+                <a:cs typeface="+mn-lt"/>
+              </a:rPr>
+              <a:t>Konsenzusni algoritam koji koristi ♦S zahtijeva većinu procesa da budu ispravni</a:t>
+            </a:r>
+            <a:endParaRPr lang="hr-HR"/>
+          </a:p>
+        </p:txBody>
+      </p:sp>
+    </p:spTree>
+    <p:extLst>
+      <p:ext uri="{BB962C8B-B14F-4D97-AF65-F5344CB8AC3E}">
+        <p14:creationId xmlns:p14="http://schemas.microsoft.com/office/powerpoint/2010/main" val="2908243834"/>
+      </p:ext>
+    </p:extLst>
+  </p:cSld>
+  <p:clrMapOvr>
+    <a:masterClrMapping/>
+  </p:clrMapOvr>
+</p:sld>
+</file>
+
 <file path=ppt/slides/slide2.xml><?xml version="1.0" encoding="utf-8"?>
 <p:sld xmlns:a="http://schemas.openxmlformats.org/drawingml/2006/main" xmlns:r="http://schemas.openxmlformats.org/officeDocument/2006/relationships" xmlns:p="http://schemas.openxmlformats.org/presentationml/2006/main">
   <p:cSld>

</xml_diff>